<commit_message>
docs(presentation): sync team PowerPoint with harness loop updates
Match the HTML slide wording for pipeline status, live loop, hostile caveat, and Starts/Checkpoints/Stops.
</commit_message>
<xml_diff>
--- a/docs/presentations/Pharmacy-Agent-Team-Presentation.pptx
+++ b/docs/presentations/Pharmacy-Agent-Team-Presentation.pptx
@@ -403,7 +403,7 @@
                 </a:solidFill>
                 <a:latin typeface="Arial"/>
               </a:rPr>
-              <a:t>Pour conclure, en trois points. Ce que nous avons construit : deux outils en lecture seule, un prompt système strict et cinq contrôles contre l'injection, tous testés sur des données synthétiques. Ce que nous avons appris : il faut tester les outils pour de vrai ; une panne ou une absence de résultat ne veut jamais dire "pas de pénurie" ; et les règles de sécurité doivent être dans le code, pas seulement dans le prompt. La suite : connecter le harnais, tester les trois cas de l'Eval Card de bout en bout, et n'utiliser de vraies données qu'après approbation. Merci ! Avez-vous des questions ?</a:t>
+              <a:t>Pour conclure, en trois points. Ce que nous avons construit : deux outils en lecture seule, un prompt système strict, cinq contrôles contre l'injection, et une boucle de revue du harnais avec un tour de modèle gardé, tous testés sur des données synthétiques. Ce que nous avons appris : il faut tester les outils pour de vrai ; une panne ou une absence de résultat ne veut jamais dire "pas de pénurie" ; et les règles de sécurité doivent être dans le code, pas seulement dans le prompt. La suite : faire évoluer le parcours de démo visible, et n'utiliser de vraies données pharmacie qu'après approbation. Le harnais avec un tour de modèle gardé est déjà connecté sur des données synthétiques. Merci ! Avez-vous des questions ?</a:t>
             </a:r>
           </a:p>
         </p:txBody>
@@ -575,7 +575,7 @@
                 </a:solidFill>
                 <a:latin typeface="Arial"/>
               </a:rPr>
-              <a:t>Voici comment les trois parties s'assemblent. Les données entrent, sont validées, réduites aux faits minimaux, puis passent au modèle. Le modèle ne peut appeler que des outils protégés, et sa réponse est vérifiée avant d'arriver à l'humain. Le tableau montre qui fait quoi : Kerrian Gordon pour le harnais, moi pour les outils et les instructions, Emmanuel De Jesus pour la protection. Ma partie et celle d'Emmanuel sont construites. Le harnais de Kerrian est prévu. La prochaine étape : tout connecter avec une vraie boucle de modèle.</a:t>
+              <a:t>Voici comment les trois parties s'assemblent. Les données entrent, les lectures passent par les gardes, puis le harnais calcule et assemble les faits. Ensuite, un seul tour de modèle peut recopier le rapport exact ; s'il invente, la réponse est refusée. Le tableau montre qui fait quoi. Les trois parties sont connectées sur des données synthétiques. La boucle s'arrête quand le rapport humain est prêt. Spoken EN: The harness starts when we run a store review, checkpoints at guarded reads, calculation, and one model copy, and stops when you get a human report — or when a bad model answer is refused and the verified facts stay on screen.</a:t>
             </a:r>
           </a:p>
         </p:txBody>
@@ -1005,7 +1005,7 @@
                 </a:solidFill>
                 <a:latin typeface="Arial"/>
               </a:rPr>
-              <a:t>Voici les attaques testées par Emmanuel et ce qui s'est passé : caractères cachés, faux rôles, JSON cassé, commandes interdites, mauvais magasin, et un modèle qui change le stock à 999. À chaque fois, c'est refusé ou remplacé par un résultat sûr. Emmanuel reste honnête : réussir ces tests ne prouve pas que toutes les attaques futures seront détectées.</a:t>
+              <a:t>Voici les attaques testées par Emmanuel et ce qui s'est passé : caractères cachés, faux rôles, JSON cassé, commandes interdites, mauvais magasin, et un modèle qui change le stock à 999. À chaque fois, c'est refusé ou remplacé par un résultat sûr. Emmanuel reste honnête : réussir ces tests ne prouve pas que toutes les attaques futures seront détectées. Ces evals testent le code et les gardes. Le comportement d'un modèle face à du texte hostile en direct n'est pas encore testé ; le design garde ce texte hors du contexte du modèle.</a:t>
             </a:r>
           </a:p>
         </p:txBody>
@@ -1091,7 +1091,7 @@
                 </a:solidFill>
                 <a:latin typeface="Arial"/>
               </a:rPr>
-              <a:t>Les preuves : 94 tests passent dans tout le projet. Sur les 85 cas de test d'Emmanuel, tous les résultats correspondent : 55 attaques détectées, 30 textes normaux acceptés, et aucune erreur. Ce sont des résultats sur les cas testés, pas une garantie contre toutes les attaques. Les prochaines étapes : connecter le harnais, les outils et les protections avec une vraie boucle de modèle, puis tester les trois cas de l'Eval Card de bout en bout.</a:t>
+              <a:t>Les preuves de détection restent celles d'Emmanuel (fixtures). En plus, le harnais tourne de bout en bout sur des données synthétiques : lectures gardées, calcul indépendant, un éventuel tour de modèle qui doit recopier le rapport exact. La boucle s'arrête quand le rapport humain est prêt, ou si la réponse du modèle est refusée ou indisponible. Le texte hostile en direct vers le modèle n'a pas été testé.</a:t>
             </a:r>
           </a:p>
         </p:txBody>
@@ -4311,7 +4311,7 @@
       </p:sp>
       <p:sp>
         <p:nvSpPr>
-          <p:cNvPr id="8" name="Two read-only tools, a strict system prompt and fi">
+          <p:cNvPr id="8" name="Two read-only tools, prompt, controls, harness loop">
             <a:extLst>
               <a:ext uri="{FF2B5EF4-FFF2-40B4-BE49-F238E27FC236}">
                 <a16:creationId xmlns:a16="http://schemas.microsoft.com/office/drawing/2014/main" id="{8C6B2376-E699-4B52-A9EB-FAA254188536}"/>
@@ -4365,7 +4365,7 @@
                 </a:solidFill>
                 <a:latin typeface="Arial"/>
               </a:rPr>
-              <a:t>Two read-only tools, a strict system prompt and five injection controls, all tested on synthetic data.</a:t>
+              <a:t>Two read-only tools, a strict system prompt, five injection controls, and a harness review loop — including one guarded model copy — on synthetic data.</a:t>
             </a:r>
           </a:p>
         </p:txBody>
@@ -4625,7 +4625,7 @@
       </p:sp>
       <p:sp>
         <p:nvSpPr>
-          <p:cNvPr id="14" name="Connect the harness, run the Eval Card end to end,">
+          <p:cNvPr id="14" name="Keep improving the demo path">
             <a:extLst>
               <a:ext uri="{FF2B5EF4-FFF2-40B4-BE49-F238E27FC236}">
                 <a16:creationId xmlns:a16="http://schemas.microsoft.com/office/drawing/2014/main" id="{B4F1C483-61B8-6E7E-052E-987BECAE4267}"/>
@@ -4679,7 +4679,7 @@
                 </a:solidFill>
                 <a:latin typeface="Arial"/>
               </a:rPr>
-              <a:t>Connect the harness, run the Eval Card end to end, and use real data only after approval.</a:t>
+              <a:t>Keep improving the demo path people see; use live pharmacy data only after approval. Harness model path is already connected on synthetic data.</a:t>
             </a:r>
           </a:p>
         </p:txBody>
@@ -5999,1150 +5999,8 @@
 </p:sld>
 </file>
 
-<file path=ppt/slides/slide3.xml><?xml version="1.0" encoding="utf-8"?>
-<p:sld xmlns:a="http://schemas.openxmlformats.org/drawingml/2006/main" xmlns:r="http://schemas.openxmlformats.org/officeDocument/2006/relationships" xmlns:p="http://schemas.openxmlformats.org/presentationml/2006/main">
-  <p:cSld name="arch">
-    <p:spTree>
-      <p:nvGrpSpPr>
-        <p:cNvPr id="1" name=""/>
-        <p:cNvGrpSpPr/>
-        <p:nvPr/>
-      </p:nvGrpSpPr>
-      <p:grpSpPr>
-        <a:xfrm>
-          <a:off x="0" y="0"/>
-          <a:ext cx="0" cy="0"/>
-          <a:chOff x="0" y="0"/>
-          <a:chExt cx="0" cy="0"/>
-        </a:xfrm>
-      </p:grpSpPr>
-      <p:sp>
-        <p:nvSpPr>
-          <p:cNvPr id="2" name="Background">
-            <a:extLst>
-              <a:ext uri="{FF2B5EF4-FFF2-40B4-BE49-F238E27FC236}">
-                <a16:creationId xmlns:a16="http://schemas.microsoft.com/office/drawing/2014/main" id="{C14C7F5C-0DB5-ABDD-3895-8EF4D0615D0C}"/>
-              </a:ext>
-            </a:extLst>
-          </p:cNvPr>
-          <p:cNvSpPr txBox="1"/>
-          <p:nvPr/>
-        </p:nvSpPr>
-        <p:spPr>
-          <a:xfrm>
-            <a:off x="0" y="0"/>
-            <a:ext cx="12192001" cy="6858000"/>
-          </a:xfrm>
-          <a:prstGeom prst="rect">
-            <a:avLst/>
-          </a:prstGeom>
-          <a:solidFill>
-            <a:srgbClr val="F7F6F2"/>
-          </a:solidFill>
-          <a:ln>
-            <a:noFill/>
-          </a:ln>
-        </p:spPr>
-        <p:txBody>
-          <a:bodyPr lIns="0" tIns="0" rIns="0" bIns="0"/>
-          <a:lstStyle/>
-          <a:p>
-            <a:endParaRPr lang="en-US"/>
-          </a:p>
-        </p:txBody>
-      </p:sp>
-      <p:sp>
-        <p:nvSpPr>
-          <p:cNvPr id="3" name="ARCHITECTURE">
-            <a:extLst>
-              <a:ext uri="{FF2B5EF4-FFF2-40B4-BE49-F238E27FC236}">
-                <a16:creationId xmlns:a16="http://schemas.microsoft.com/office/drawing/2014/main" id="{6E8CED4E-396E-238B-3B51-F99A757A206D}"/>
-              </a:ext>
-            </a:extLst>
-          </p:cNvPr>
-          <p:cNvSpPr txBox="1"/>
-          <p:nvPr/>
-        </p:nvSpPr>
-        <p:spPr>
-          <a:xfrm>
-            <a:off x="812800" y="812800"/>
-            <a:ext cx="10566399" cy="254001"/>
-          </a:xfrm>
-          <a:prstGeom prst="rect">
-            <a:avLst/>
-          </a:prstGeom>
-          <a:noFill/>
-          <a:ln>
-            <a:noFill/>
-          </a:ln>
-        </p:spPr>
-        <p:txBody>
-          <a:bodyPr lIns="0" tIns="0" rIns="0" bIns="0" anchor="t">
-            <a:noAutofit/>
-          </a:bodyPr>
-          <a:lstStyle/>
-          <a:p>
-            <a:pPr lvl="0">
-              <a:lnSpc>
-                <a:spcPct val="120000"/>
-              </a:lnSpc>
-              <a:spcBef>
-                <a:spcPts val="0"/>
-              </a:spcBef>
-              <a:spcAft>
-                <a:spcPts val="0"/>
-              </a:spcAft>
-              <a:buNone/>
-              <a:defRPr sz="1200" b="0">
-                <a:solidFill>
-                  <a:srgbClr val="B44E14"/>
-                </a:solidFill>
-                <a:latin typeface="Courier New"/>
-              </a:defRPr>
-            </a:pPr>
-            <a:r>
-              <a:rPr lang="en-US" sz="1200" b="0">
-                <a:solidFill>
-                  <a:srgbClr val="B44E14"/>
-                </a:solidFill>
-                <a:latin typeface="Courier New"/>
-              </a:rPr>
-              <a:t>ARCHITECTURE</a:t>
-            </a:r>
-          </a:p>
-        </p:txBody>
-      </p:sp>
-      <p:sp>
-        <p:nvSpPr>
-          <p:cNvPr id="4" name="Three parts, every step guarded">
-            <a:extLst>
-              <a:ext uri="{FF2B5EF4-FFF2-40B4-BE49-F238E27FC236}">
-                <a16:creationId xmlns:a16="http://schemas.microsoft.com/office/drawing/2014/main" id="{B90BEA9F-C1F6-2274-423E-D913BCAD32CA}"/>
-              </a:ext>
-            </a:extLst>
-          </p:cNvPr>
-          <p:cNvSpPr txBox="1"/>
-          <p:nvPr/>
-        </p:nvSpPr>
-        <p:spPr>
-          <a:xfrm>
-            <a:off x="812800" y="1143000"/>
-            <a:ext cx="10566399" cy="984250"/>
-          </a:xfrm>
-          <a:prstGeom prst="rect">
-            <a:avLst/>
-          </a:prstGeom>
-          <a:noFill/>
-          <a:ln>
-            <a:noFill/>
-          </a:ln>
-        </p:spPr>
-        <p:txBody>
-          <a:bodyPr lIns="0" tIns="0" rIns="0" bIns="0" anchor="t">
-            <a:noAutofit/>
-          </a:bodyPr>
-          <a:lstStyle/>
-          <a:p>
-            <a:pPr lvl="0">
-              <a:lnSpc>
-                <a:spcPct val="110000"/>
-              </a:lnSpc>
-              <a:spcBef>
-                <a:spcPts val="0"/>
-              </a:spcBef>
-              <a:spcAft>
-                <a:spcPts val="0"/>
-              </a:spcAft>
-              <a:buNone/>
-              <a:defRPr sz="3200" b="1">
-                <a:solidFill>
-                  <a:srgbClr val="14213D"/>
-                </a:solidFill>
-                <a:latin typeface="Arial"/>
-              </a:defRPr>
-            </a:pPr>
-            <a:r>
-              <a:rPr lang="en-US" sz="3200" b="1">
-                <a:solidFill>
-                  <a:srgbClr val="14213D"/>
-                </a:solidFill>
-                <a:latin typeface="Arial"/>
-              </a:rPr>
-              <a:t>Three parts, every step guarded</a:t>
-            </a:r>
-          </a:p>
-        </p:txBody>
-      </p:sp>
-      <p:sp>
-        <p:nvSpPr>
-          <p:cNvPr id="5" name="Pharmacy-AGENT · Synthetic tests; human operationa">
-            <a:extLst>
-              <a:ext uri="{FF2B5EF4-FFF2-40B4-BE49-F238E27FC236}">
-                <a16:creationId xmlns:a16="http://schemas.microsoft.com/office/drawing/2014/main" id="{B44CA3A5-DF7C-B4B1-CF35-B39B47E231FF}"/>
-              </a:ext>
-            </a:extLst>
-          </p:cNvPr>
-          <p:cNvSpPr txBox="1"/>
-          <p:nvPr/>
-        </p:nvSpPr>
-        <p:spPr>
-          <a:xfrm>
-            <a:off x="812800" y="6222999"/>
-            <a:ext cx="10566399" cy="279399"/>
-          </a:xfrm>
-          <a:prstGeom prst="rect">
-            <a:avLst/>
-          </a:prstGeom>
-          <a:noFill/>
-          <a:ln>
-            <a:noFill/>
-          </a:ln>
-        </p:spPr>
-        <p:txBody>
-          <a:bodyPr lIns="0" tIns="0" rIns="0" bIns="0" anchor="t">
-            <a:noAutofit/>
-          </a:bodyPr>
-          <a:lstStyle/>
-          <a:p>
-            <a:pPr lvl="0">
-              <a:lnSpc>
-                <a:spcPct val="120000"/>
-              </a:lnSpc>
-              <a:spcBef>
-                <a:spcPts val="0"/>
-              </a:spcBef>
-              <a:spcAft>
-                <a:spcPts val="0"/>
-              </a:spcAft>
-              <a:buNone/>
-              <a:defRPr sz="1200" b="0">
-                <a:solidFill>
-                  <a:srgbClr val="6A7385"/>
-                </a:solidFill>
-                <a:latin typeface="Arial"/>
-              </a:defRPr>
-            </a:pPr>
-            <a:r>
-              <a:rPr lang="en-US" sz="1200" b="0">
-                <a:solidFill>
-                  <a:srgbClr val="6A7385"/>
-                </a:solidFill>
-                <a:latin typeface="Arial"/>
-              </a:rPr>
-              <a:t>Pharmacy-AGENT · Synthetic tests; human operational decisions · 3 / 10</a:t>
-            </a:r>
-          </a:p>
-        </p:txBody>
-      </p:sp>
-      <p:sp>
-        <p:nvSpPr>
-          <p:cNvPr id="6" name="Background">
-            <a:extLst>
-              <a:ext uri="{FF2B5EF4-FFF2-40B4-BE49-F238E27FC236}">
-                <a16:creationId xmlns:a16="http://schemas.microsoft.com/office/drawing/2014/main" id="{78CB14F0-6999-E156-9039-E345A07641E6}"/>
-              </a:ext>
-            </a:extLst>
-          </p:cNvPr>
-          <p:cNvSpPr txBox="1"/>
-          <p:nvPr/>
-        </p:nvSpPr>
-        <p:spPr>
-          <a:xfrm>
-            <a:off x="812800" y="1854201"/>
-            <a:ext cx="10566399" cy="571500"/>
-          </a:xfrm>
-          <a:prstGeom prst="rect">
-            <a:avLst/>
-          </a:prstGeom>
-          <a:solidFill>
-            <a:srgbClr val="E8EBF1"/>
-          </a:solidFill>
-          <a:ln>
-            <a:noFill/>
-          </a:ln>
-        </p:spPr>
-        <p:txBody>
-          <a:bodyPr lIns="0" tIns="0" rIns="0" bIns="0"/>
-          <a:lstStyle/>
-          <a:p>
-            <a:endParaRPr lang="en-US"/>
-          </a:p>
-        </p:txBody>
-      </p:sp>
-      <p:sp>
-        <p:nvSpPr>
-          <p:cNvPr id="7" name="Input → validation → minimal facts → model → guard">
-            <a:extLst>
-              <a:ext uri="{FF2B5EF4-FFF2-40B4-BE49-F238E27FC236}">
-                <a16:creationId xmlns:a16="http://schemas.microsoft.com/office/drawing/2014/main" id="{C0AB4FCF-4861-AD57-1148-6196C4DD1EBE}"/>
-              </a:ext>
-            </a:extLst>
-          </p:cNvPr>
-          <p:cNvSpPr txBox="1"/>
-          <p:nvPr/>
-        </p:nvSpPr>
-        <p:spPr>
-          <a:xfrm>
-            <a:off x="990601" y="2006600"/>
-            <a:ext cx="10210798" cy="380998"/>
-          </a:xfrm>
-          <a:prstGeom prst="rect">
-            <a:avLst/>
-          </a:prstGeom>
-          <a:noFill/>
-          <a:ln>
-            <a:noFill/>
-          </a:ln>
-        </p:spPr>
-        <p:txBody>
-          <a:bodyPr lIns="0" tIns="0" rIns="0" bIns="0" anchor="t">
-            <a:noAutofit/>
-          </a:bodyPr>
-          <a:lstStyle/>
-          <a:p>
-            <a:pPr lvl="0">
-              <a:lnSpc>
-                <a:spcPct val="120000"/>
-              </a:lnSpc>
-              <a:spcBef>
-                <a:spcPts val="0"/>
-              </a:spcBef>
-              <a:spcAft>
-                <a:spcPts val="0"/>
-              </a:spcAft>
-              <a:buNone/>
-              <a:defRPr sz="1300" b="0">
-                <a:solidFill>
-                  <a:srgbClr val="14213D"/>
-                </a:solidFill>
-                <a:latin typeface="Courier New"/>
-              </a:defRPr>
-            </a:pPr>
-            <a:r>
-              <a:rPr lang="en-US" sz="1300" b="0">
-                <a:solidFill>
-                  <a:srgbClr val="14213D"/>
-                </a:solidFill>
-                <a:latin typeface="Courier New"/>
-              </a:rPr>
-              <a:t>Input → validation → minimal facts → model → guarded tools → output → human</a:t>
-            </a:r>
-          </a:p>
-        </p:txBody>
-      </p:sp>
-      <p:graphicFrame>
-        <p:nvGraphicFramePr>
-          <p:cNvPr id="8" name="Table 7">
-            <a:extLst>
-              <a:ext uri="{FF2B5EF4-FFF2-40B4-BE49-F238E27FC236}">
-                <a16:creationId xmlns:a16="http://schemas.microsoft.com/office/drawing/2014/main" id="{8A47B976-AB0B-6087-E5C3-591297443A8E}"/>
-              </a:ext>
-            </a:extLst>
-          </p:cNvPr>
-          <p:cNvGraphicFramePr>
-            <a:graphicFrameLocks noGrp="1"/>
-          </p:cNvGraphicFramePr>
-          <p:nvPr/>
-        </p:nvGraphicFramePr>
-        <p:xfrm>
-          <a:off x="812800" y="2730499"/>
-          <a:ext cx="10566399" cy="1574798"/>
-        </p:xfrm>
-        <a:graphic>
-          <a:graphicData uri="http://schemas.openxmlformats.org/drawingml/2006/table">
-            <a:tbl>
-              <a:tblPr/>
-              <a:tblGrid>
-                <a:gridCol w="2535937">
-                  <a:extLst>
-                    <a:ext uri="{9D8B030D-6E8A-4147-A177-3AD203B41FA5}">
-                      <a16:colId xmlns:a16="http://schemas.microsoft.com/office/drawing/2014/main" val="1096448313"/>
-                    </a:ext>
-                  </a:extLst>
-                </a:gridCol>
-                <a:gridCol w="2535937">
-                  <a:extLst>
-                    <a:ext uri="{9D8B030D-6E8A-4147-A177-3AD203B41FA5}">
-                      <a16:colId xmlns:a16="http://schemas.microsoft.com/office/drawing/2014/main" val="1922132533"/>
-                    </a:ext>
-                  </a:extLst>
-                </a:gridCol>
-                <a:gridCol w="5494528">
-                  <a:extLst>
-                    <a:ext uri="{9D8B030D-6E8A-4147-A177-3AD203B41FA5}">
-                      <a16:colId xmlns:a16="http://schemas.microsoft.com/office/drawing/2014/main" val="3085363466"/>
-                    </a:ext>
-                  </a:extLst>
-                </a:gridCol>
-              </a:tblGrid>
-              <a:tr h="393699">
-                <a:tc>
-                  <a:txBody>
-                    <a:bodyPr/>
-                    <a:lstStyle/>
-                    <a:p>
-                      <a:pPr lvl="0">
-                        <a:lnSpc>
-                          <a:spcPct val="125000"/>
-                        </a:lnSpc>
-                        <a:spcBef>
-                          <a:spcPts val="0"/>
-                        </a:spcBef>
-                        <a:spcAft>
-                          <a:spcPts val="0"/>
-                        </a:spcAft>
-                        <a:buNone/>
-                        <a:defRPr sz="1300" b="1">
-                          <a:solidFill>
-                            <a:srgbClr val="14213D"/>
-                          </a:solidFill>
-                          <a:latin typeface="Arial"/>
-                        </a:defRPr>
-                      </a:pPr>
-                      <a:r>
-                        <a:rPr lang="en-US" sz="1300" b="1">
-                          <a:solidFill>
-                            <a:srgbClr val="14213D"/>
-                          </a:solidFill>
-                          <a:latin typeface="Arial"/>
-                        </a:rPr>
-                        <a:t>Component</a:t>
-                      </a:r>
-                    </a:p>
-                  </a:txBody>
-                  <a:tcPr>
-                    <a:lnB w="7200" cap="flat" cmpd="sng" algn="ctr">
-                      <a:solidFill>
-                        <a:srgbClr val="DCDFE5"/>
-                      </a:solidFill>
-                      <a:prstDash val="solid"/>
-                      <a:round/>
-                      <a:headEnd type="none" w="med" len="med"/>
-                      <a:tailEnd type="none" w="med" len="med"/>
-                    </a:lnB>
-                    <a:solidFill>
-                      <a:srgbClr val="F7F6F2"/>
-                    </a:solidFill>
-                  </a:tcPr>
-                </a:tc>
-                <a:tc>
-                  <a:txBody>
-                    <a:bodyPr/>
-                    <a:lstStyle/>
-                    <a:p>
-                      <a:pPr lvl="0">
-                        <a:lnSpc>
-                          <a:spcPct val="125000"/>
-                        </a:lnSpc>
-                        <a:spcBef>
-                          <a:spcPts val="0"/>
-                        </a:spcBef>
-                        <a:spcAft>
-                          <a:spcPts val="0"/>
-                        </a:spcAft>
-                        <a:buNone/>
-                        <a:defRPr sz="1300" b="1">
-                          <a:solidFill>
-                            <a:srgbClr val="14213D"/>
-                          </a:solidFill>
-                          <a:latin typeface="Arial"/>
-                        </a:defRPr>
-                      </a:pPr>
-                      <a:r>
-                        <a:rPr lang="en-US" sz="1300" b="1">
-                          <a:solidFill>
-                            <a:srgbClr val="14213D"/>
-                          </a:solidFill>
-                          <a:latin typeface="Arial"/>
-                        </a:rPr>
-                        <a:t>Owner</a:t>
-                      </a:r>
-                    </a:p>
-                  </a:txBody>
-                  <a:tcPr>
-                    <a:lnB w="7200" cap="flat" cmpd="sng" algn="ctr">
-                      <a:solidFill>
-                        <a:srgbClr val="DCDFE5"/>
-                      </a:solidFill>
-                      <a:prstDash val="solid"/>
-                      <a:round/>
-                      <a:headEnd type="none" w="med" len="med"/>
-                      <a:tailEnd type="none" w="med" len="med"/>
-                    </a:lnB>
-                    <a:solidFill>
-                      <a:srgbClr val="F7F6F2"/>
-                    </a:solidFill>
-                  </a:tcPr>
-                </a:tc>
-                <a:tc>
-                  <a:txBody>
-                    <a:bodyPr/>
-                    <a:lstStyle/>
-                    <a:p>
-                      <a:pPr lvl="0">
-                        <a:lnSpc>
-                          <a:spcPct val="125000"/>
-                        </a:lnSpc>
-                        <a:spcBef>
-                          <a:spcPts val="0"/>
-                        </a:spcBef>
-                        <a:spcAft>
-                          <a:spcPts val="0"/>
-                        </a:spcAft>
-                        <a:buNone/>
-                        <a:defRPr sz="1300" b="1">
-                          <a:solidFill>
-                            <a:srgbClr val="14213D"/>
-                          </a:solidFill>
-                          <a:latin typeface="Arial"/>
-                        </a:defRPr>
-                      </a:pPr>
-                      <a:r>
-                        <a:rPr lang="en-US" sz="1300" b="1">
-                          <a:solidFill>
-                            <a:srgbClr val="14213D"/>
-                          </a:solidFill>
-                          <a:latin typeface="Arial"/>
-                        </a:rPr>
-                        <a:t>Responsibility</a:t>
-                      </a:r>
-                    </a:p>
-                  </a:txBody>
-                  <a:tcPr>
-                    <a:lnB w="7200" cap="flat" cmpd="sng" algn="ctr">
-                      <a:solidFill>
-                        <a:srgbClr val="DCDFE5"/>
-                      </a:solidFill>
-                      <a:prstDash val="solid"/>
-                      <a:round/>
-                      <a:headEnd type="none" w="med" len="med"/>
-                      <a:tailEnd type="none" w="med" len="med"/>
-                    </a:lnB>
-                    <a:solidFill>
-                      <a:srgbClr val="F7F6F2"/>
-                    </a:solidFill>
-                  </a:tcPr>
-                </a:tc>
-                <a:extLst>
-                  <a:ext uri="{0D108BD9-81ED-4DB2-BD59-A6C34878D82A}">
-                    <a16:rowId xmlns:a16="http://schemas.microsoft.com/office/drawing/2014/main" val="2096825301"/>
-                  </a:ext>
-                </a:extLst>
-              </a:tr>
-              <a:tr h="393699">
-                <a:tc>
-                  <a:txBody>
-                    <a:bodyPr/>
-                    <a:lstStyle/>
-                    <a:p>
-                      <a:pPr lvl="0">
-                        <a:lnSpc>
-                          <a:spcPct val="125000"/>
-                        </a:lnSpc>
-                        <a:spcBef>
-                          <a:spcPts val="0"/>
-                        </a:spcBef>
-                        <a:spcAft>
-                          <a:spcPts val="0"/>
-                        </a:spcAft>
-                        <a:buNone/>
-                        <a:defRPr sz="1300" b="0">
-                          <a:solidFill>
-                            <a:srgbClr val="14213D"/>
-                          </a:solidFill>
-                          <a:latin typeface="Arial"/>
-                        </a:defRPr>
-                      </a:pPr>
-                      <a:r>
-                        <a:rPr lang="en-US" sz="1300" b="0">
-                          <a:solidFill>
-                            <a:srgbClr val="14213D"/>
-                          </a:solidFill>
-                          <a:latin typeface="Arial"/>
-                        </a:rPr>
-                        <a:t>Harness</a:t>
-                      </a:r>
-                    </a:p>
-                  </a:txBody>
-                  <a:tcPr>
-                    <a:lnT w="7200" cap="flat" cmpd="sng" algn="ctr">
-                      <a:solidFill>
-                        <a:srgbClr val="DCDFE5"/>
-                      </a:solidFill>
-                      <a:prstDash val="solid"/>
-                      <a:round/>
-                      <a:headEnd type="none" w="med" len="med"/>
-                      <a:tailEnd type="none" w="med" len="med"/>
-                    </a:lnT>
-                    <a:lnB w="7200" cap="flat" cmpd="sng" algn="ctr">
-                      <a:solidFill>
-                        <a:srgbClr val="DCDFE5"/>
-                      </a:solidFill>
-                      <a:prstDash val="solid"/>
-                      <a:round/>
-                      <a:headEnd type="none" w="med" len="med"/>
-                      <a:tailEnd type="none" w="med" len="med"/>
-                    </a:lnB>
-                    <a:solidFill>
-                      <a:srgbClr val="F7F6F2"/>
-                    </a:solidFill>
-                  </a:tcPr>
-                </a:tc>
-                <a:tc>
-                  <a:txBody>
-                    <a:bodyPr/>
-                    <a:lstStyle/>
-                    <a:p>
-                      <a:pPr lvl="0">
-                        <a:lnSpc>
-                          <a:spcPct val="125000"/>
-                        </a:lnSpc>
-                        <a:spcBef>
-                          <a:spcPts val="0"/>
-                        </a:spcBef>
-                        <a:spcAft>
-                          <a:spcPts val="0"/>
-                        </a:spcAft>
-                        <a:buNone/>
-                        <a:defRPr sz="1300" b="0">
-                          <a:solidFill>
-                            <a:srgbClr val="14213D"/>
-                          </a:solidFill>
-                          <a:latin typeface="Arial"/>
-                        </a:defRPr>
-                      </a:pPr>
-                      <a:r>
-                        <a:rPr lang="en-US" sz="1300" b="0">
-                          <a:solidFill>
-                            <a:srgbClr val="14213D"/>
-                          </a:solidFill>
-                          <a:latin typeface="Arial"/>
-                        </a:rPr>
-                        <a:t>Kerrian Gordon</a:t>
-                      </a:r>
-                    </a:p>
-                  </a:txBody>
-                  <a:tcPr>
-                    <a:lnT w="7200" cap="flat" cmpd="sng" algn="ctr">
-                      <a:solidFill>
-                        <a:srgbClr val="DCDFE5"/>
-                      </a:solidFill>
-                      <a:prstDash val="solid"/>
-                      <a:round/>
-                      <a:headEnd type="none" w="med" len="med"/>
-                      <a:tailEnd type="none" w="med" len="med"/>
-                    </a:lnT>
-                    <a:lnB w="7200" cap="flat" cmpd="sng" algn="ctr">
-                      <a:solidFill>
-                        <a:srgbClr val="DCDFE5"/>
-                      </a:solidFill>
-                      <a:prstDash val="solid"/>
-                      <a:round/>
-                      <a:headEnd type="none" w="med" len="med"/>
-                      <a:tailEnd type="none" w="med" len="med"/>
-                    </a:lnB>
-                    <a:solidFill>
-                      <a:srgbClr val="F7F6F2"/>
-                    </a:solidFill>
-                  </a:tcPr>
-                </a:tc>
-                <a:tc>
-                  <a:txBody>
-                    <a:bodyPr/>
-                    <a:lstStyle/>
-                    <a:p>
-                      <a:pPr lvl="0">
-                        <a:lnSpc>
-                          <a:spcPct val="125000"/>
-                        </a:lnSpc>
-                        <a:spcBef>
-                          <a:spcPts val="0"/>
-                        </a:spcBef>
-                        <a:spcAft>
-                          <a:spcPts val="0"/>
-                        </a:spcAft>
-                        <a:buNone/>
-                        <a:defRPr sz="1300" b="0">
-                          <a:solidFill>
-                            <a:srgbClr val="14213D"/>
-                          </a:solidFill>
-                          <a:latin typeface="Arial"/>
-                        </a:defRPr>
-                      </a:pPr>
-                      <a:r>
-                        <a:rPr lang="en-US" sz="1300" b="0">
-                          <a:solidFill>
-                            <a:srgbClr val="14213D"/>
-                          </a:solidFill>
-                          <a:latin typeface="Arial"/>
-                        </a:rPr>
-                        <a:t>Verify units, freshness, policy; calculate; run the loop</a:t>
-                      </a:r>
-                    </a:p>
-                  </a:txBody>
-                  <a:tcPr>
-                    <a:lnT w="7200" cap="flat" cmpd="sng" algn="ctr">
-                      <a:solidFill>
-                        <a:srgbClr val="DCDFE5"/>
-                      </a:solidFill>
-                      <a:prstDash val="solid"/>
-                      <a:round/>
-                      <a:headEnd type="none" w="med" len="med"/>
-                      <a:tailEnd type="none" w="med" len="med"/>
-                    </a:lnT>
-                    <a:lnB w="7200" cap="flat" cmpd="sng" algn="ctr">
-                      <a:solidFill>
-                        <a:srgbClr val="DCDFE5"/>
-                      </a:solidFill>
-                      <a:prstDash val="solid"/>
-                      <a:round/>
-                      <a:headEnd type="none" w="med" len="med"/>
-                      <a:tailEnd type="none" w="med" len="med"/>
-                    </a:lnB>
-                    <a:solidFill>
-                      <a:srgbClr val="F7F6F2"/>
-                    </a:solidFill>
-                  </a:tcPr>
-                </a:tc>
-                <a:extLst>
-                  <a:ext uri="{0D108BD9-81ED-4DB2-BD59-A6C34878D82A}">
-                    <a16:rowId xmlns:a16="http://schemas.microsoft.com/office/drawing/2014/main" val="2001623680"/>
-                  </a:ext>
-                </a:extLst>
-              </a:tr>
-              <a:tr h="393699">
-                <a:tc>
-                  <a:txBody>
-                    <a:bodyPr/>
-                    <a:lstStyle/>
-                    <a:p>
-                      <a:pPr lvl="0">
-                        <a:lnSpc>
-                          <a:spcPct val="125000"/>
-                        </a:lnSpc>
-                        <a:spcBef>
-                          <a:spcPts val="0"/>
-                        </a:spcBef>
-                        <a:spcAft>
-                          <a:spcPts val="0"/>
-                        </a:spcAft>
-                        <a:buNone/>
-                        <a:defRPr sz="1300" b="0">
-                          <a:solidFill>
-                            <a:srgbClr val="14213D"/>
-                          </a:solidFill>
-                          <a:latin typeface="Arial"/>
-                        </a:defRPr>
-                      </a:pPr>
-                      <a:r>
-                        <a:rPr lang="en-US" sz="1300" b="0">
-                          <a:solidFill>
-                            <a:srgbClr val="14213D"/>
-                          </a:solidFill>
-                          <a:latin typeface="Arial"/>
-                        </a:rPr>
-                        <a:t>Tools + instructions</a:t>
-                      </a:r>
-                    </a:p>
-                  </a:txBody>
-                  <a:tcPr>
-                    <a:lnT w="7200" cap="flat" cmpd="sng" algn="ctr">
-                      <a:solidFill>
-                        <a:srgbClr val="DCDFE5"/>
-                      </a:solidFill>
-                      <a:prstDash val="solid"/>
-                      <a:round/>
-                      <a:headEnd type="none" w="med" len="med"/>
-                      <a:tailEnd type="none" w="med" len="med"/>
-                    </a:lnT>
-                    <a:lnB w="7200" cap="flat" cmpd="sng" algn="ctr">
-                      <a:solidFill>
-                        <a:srgbClr val="DCDFE5"/>
-                      </a:solidFill>
-                      <a:prstDash val="solid"/>
-                      <a:round/>
-                      <a:headEnd type="none" w="med" len="med"/>
-                      <a:tailEnd type="none" w="med" len="med"/>
-                    </a:lnB>
-                    <a:solidFill>
-                      <a:srgbClr val="F7F6F2"/>
-                    </a:solidFill>
-                  </a:tcPr>
-                </a:tc>
-                <a:tc>
-                  <a:txBody>
-                    <a:bodyPr/>
-                    <a:lstStyle/>
-                    <a:p>
-                      <a:pPr lvl="0">
-                        <a:lnSpc>
-                          <a:spcPct val="125000"/>
-                        </a:lnSpc>
-                        <a:spcBef>
-                          <a:spcPts val="0"/>
-                        </a:spcBef>
-                        <a:spcAft>
-                          <a:spcPts val="0"/>
-                        </a:spcAft>
-                        <a:buNone/>
-                        <a:defRPr sz="1300" b="0">
-                          <a:solidFill>
-                            <a:srgbClr val="14213D"/>
-                          </a:solidFill>
-                          <a:latin typeface="Arial"/>
-                        </a:defRPr>
-                      </a:pPr>
-                      <a:r>
-                        <a:rPr lang="en-US" sz="1300" b="0">
-                          <a:solidFill>
-                            <a:srgbClr val="14213D"/>
-                          </a:solidFill>
-                          <a:latin typeface="Arial"/>
-                        </a:rPr>
-                        <a:t>Brahim Maouloud</a:t>
-                      </a:r>
-                    </a:p>
-                  </a:txBody>
-                  <a:tcPr>
-                    <a:lnT w="7200" cap="flat" cmpd="sng" algn="ctr">
-                      <a:solidFill>
-                        <a:srgbClr val="DCDFE5"/>
-                      </a:solidFill>
-                      <a:prstDash val="solid"/>
-                      <a:round/>
-                      <a:headEnd type="none" w="med" len="med"/>
-                      <a:tailEnd type="none" w="med" len="med"/>
-                    </a:lnT>
-                    <a:lnB w="7200" cap="flat" cmpd="sng" algn="ctr">
-                      <a:solidFill>
-                        <a:srgbClr val="DCDFE5"/>
-                      </a:solidFill>
-                      <a:prstDash val="solid"/>
-                      <a:round/>
-                      <a:headEnd type="none" w="med" len="med"/>
-                      <a:tailEnd type="none" w="med" len="med"/>
-                    </a:lnB>
-                    <a:solidFill>
-                      <a:srgbClr val="F7F6F2"/>
-                    </a:solidFill>
-                  </a:tcPr>
-                </a:tc>
-                <a:tc>
-                  <a:txBody>
-                    <a:bodyPr/>
-                    <a:lstStyle/>
-                    <a:p>
-                      <a:pPr lvl="0">
-                        <a:lnSpc>
-                          <a:spcPct val="125000"/>
-                        </a:lnSpc>
-                        <a:spcBef>
-                          <a:spcPts val="0"/>
-                        </a:spcBef>
-                        <a:spcAft>
-                          <a:spcPts val="0"/>
-                        </a:spcAft>
-                        <a:buNone/>
-                        <a:defRPr sz="1300" b="0">
-                          <a:solidFill>
-                            <a:srgbClr val="14213D"/>
-                          </a:solidFill>
-                          <a:latin typeface="Arial"/>
-                        </a:defRPr>
-                      </a:pPr>
-                      <a:r>
-                        <a:rPr lang="en-US" sz="1300" b="0">
-                          <a:solidFill>
-                            <a:srgbClr val="14213D"/>
-                          </a:solidFill>
-                          <a:latin typeface="Arial"/>
-                        </a:rPr>
-                        <a:t>Inventory reader, FDA adapter, system prompt</a:t>
-                      </a:r>
-                    </a:p>
-                  </a:txBody>
-                  <a:tcPr>
-                    <a:lnT w="7200" cap="flat" cmpd="sng" algn="ctr">
-                      <a:solidFill>
-                        <a:srgbClr val="DCDFE5"/>
-                      </a:solidFill>
-                      <a:prstDash val="solid"/>
-                      <a:round/>
-                      <a:headEnd type="none" w="med" len="med"/>
-                      <a:tailEnd type="none" w="med" len="med"/>
-                    </a:lnT>
-                    <a:lnB w="7200" cap="flat" cmpd="sng" algn="ctr">
-                      <a:solidFill>
-                        <a:srgbClr val="DCDFE5"/>
-                      </a:solidFill>
-                      <a:prstDash val="solid"/>
-                      <a:round/>
-                      <a:headEnd type="none" w="med" len="med"/>
-                      <a:tailEnd type="none" w="med" len="med"/>
-                    </a:lnB>
-                    <a:solidFill>
-                      <a:srgbClr val="F7F6F2"/>
-                    </a:solidFill>
-                  </a:tcPr>
-                </a:tc>
-                <a:extLst>
-                  <a:ext uri="{0D108BD9-81ED-4DB2-BD59-A6C34878D82A}">
-                    <a16:rowId xmlns:a16="http://schemas.microsoft.com/office/drawing/2014/main" val="2477041316"/>
-                  </a:ext>
-                </a:extLst>
-              </a:tr>
-              <a:tr h="393699">
-                <a:tc>
-                  <a:txBody>
-                    <a:bodyPr/>
-                    <a:lstStyle/>
-                    <a:p>
-                      <a:pPr lvl="0">
-                        <a:lnSpc>
-                          <a:spcPct val="125000"/>
-                        </a:lnSpc>
-                        <a:spcBef>
-                          <a:spcPts val="0"/>
-                        </a:spcBef>
-                        <a:spcAft>
-                          <a:spcPts val="0"/>
-                        </a:spcAft>
-                        <a:buNone/>
-                        <a:defRPr sz="1300" b="0">
-                          <a:solidFill>
-                            <a:srgbClr val="14213D"/>
-                          </a:solidFill>
-                          <a:latin typeface="Arial"/>
-                        </a:defRPr>
-                      </a:pPr>
-                      <a:r>
-                        <a:rPr lang="en-US" sz="1300" b="0">
-                          <a:solidFill>
-                            <a:srgbClr val="14213D"/>
-                          </a:solidFill>
-                          <a:latin typeface="Arial"/>
-                        </a:rPr>
-                        <a:t>Prevention</a:t>
-                      </a:r>
-                    </a:p>
-                  </a:txBody>
-                  <a:tcPr>
-                    <a:lnT w="7200" cap="flat" cmpd="sng" algn="ctr">
-                      <a:solidFill>
-                        <a:srgbClr val="DCDFE5"/>
-                      </a:solidFill>
-                      <a:prstDash val="solid"/>
-                      <a:round/>
-                      <a:headEnd type="none" w="med" len="med"/>
-                      <a:tailEnd type="none" w="med" len="med"/>
-                    </a:lnT>
-                    <a:lnB w="7200" cap="flat" cmpd="sng" algn="ctr">
-                      <a:solidFill>
-                        <a:srgbClr val="DCDFE5"/>
-                      </a:solidFill>
-                      <a:prstDash val="solid"/>
-                      <a:round/>
-                      <a:headEnd type="none" w="med" len="med"/>
-                      <a:tailEnd type="none" w="med" len="med"/>
-                    </a:lnB>
-                    <a:solidFill>
-                      <a:srgbClr val="F7F6F2"/>
-                    </a:solidFill>
-                  </a:tcPr>
-                </a:tc>
-                <a:tc>
-                  <a:txBody>
-                    <a:bodyPr/>
-                    <a:lstStyle/>
-                    <a:p>
-                      <a:pPr lvl="0">
-                        <a:lnSpc>
-                          <a:spcPct val="125000"/>
-                        </a:lnSpc>
-                        <a:spcBef>
-                          <a:spcPts val="0"/>
-                        </a:spcBef>
-                        <a:spcAft>
-                          <a:spcPts val="0"/>
-                        </a:spcAft>
-                        <a:buNone/>
-                        <a:defRPr sz="1300" b="0">
-                          <a:solidFill>
-                            <a:srgbClr val="14213D"/>
-                          </a:solidFill>
-                          <a:latin typeface="Arial"/>
-                        </a:defRPr>
-                      </a:pPr>
-                      <a:r>
-                        <a:rPr lang="en-US" sz="1300" b="0">
-                          <a:solidFill>
-                            <a:srgbClr val="14213D"/>
-                          </a:solidFill>
-                          <a:latin typeface="Arial"/>
-                        </a:rPr>
-                        <a:t>Emmanuel De Jesus</a:t>
-                      </a:r>
-                    </a:p>
-                  </a:txBody>
-                  <a:tcPr>
-                    <a:lnT w="7200" cap="flat" cmpd="sng" algn="ctr">
-                      <a:solidFill>
-                        <a:srgbClr val="DCDFE5"/>
-                      </a:solidFill>
-                      <a:prstDash val="solid"/>
-                      <a:round/>
-                      <a:headEnd type="none" w="med" len="med"/>
-                      <a:tailEnd type="none" w="med" len="med"/>
-                    </a:lnT>
-                    <a:lnB w="7200" cap="flat" cmpd="sng" algn="ctr">
-                      <a:solidFill>
-                        <a:srgbClr val="DCDFE5"/>
-                      </a:solidFill>
-                      <a:prstDash val="solid"/>
-                      <a:round/>
-                      <a:headEnd type="none" w="med" len="med"/>
-                      <a:tailEnd type="none" w="med" len="med"/>
-                    </a:lnB>
-                    <a:solidFill>
-                      <a:srgbClr val="F7F6F2"/>
-                    </a:solidFill>
-                  </a:tcPr>
-                </a:tc>
-                <a:tc>
-                  <a:txBody>
-                    <a:bodyPr/>
-                    <a:lstStyle/>
-                    <a:p>
-                      <a:pPr lvl="0">
-                        <a:lnSpc>
-                          <a:spcPct val="125000"/>
-                        </a:lnSpc>
-                        <a:spcBef>
-                          <a:spcPts val="0"/>
-                        </a:spcBef>
-                        <a:spcAft>
-                          <a:spcPts val="0"/>
-                        </a:spcAft>
-                        <a:buNone/>
-                        <a:defRPr sz="1300" b="0">
-                          <a:solidFill>
-                            <a:srgbClr val="14213D"/>
-                          </a:solidFill>
-                          <a:latin typeface="Arial"/>
-                        </a:defRPr>
-                      </a:pPr>
-                      <a:r>
-                        <a:rPr lang="en-US" sz="1300" b="0">
-                          <a:solidFill>
-                            <a:srgbClr val="14213D"/>
-                          </a:solidFill>
-                          <a:latin typeface="Arial"/>
-                        </a:rPr>
-                        <a:t>Isolate context; enforce action and output contracts</a:t>
-                      </a:r>
-                    </a:p>
-                  </a:txBody>
-                  <a:tcPr>
-                    <a:lnT w="7200" cap="flat" cmpd="sng" algn="ctr">
-                      <a:solidFill>
-                        <a:srgbClr val="DCDFE5"/>
-                      </a:solidFill>
-                      <a:prstDash val="solid"/>
-                      <a:round/>
-                      <a:headEnd type="none" w="med" len="med"/>
-                      <a:tailEnd type="none" w="med" len="med"/>
-                    </a:lnT>
-                    <a:lnB w="7200" cap="flat" cmpd="sng" algn="ctr">
-                      <a:solidFill>
-                        <a:srgbClr val="DCDFE5"/>
-                      </a:solidFill>
-                      <a:prstDash val="solid"/>
-                      <a:round/>
-                      <a:headEnd type="none" w="med" len="med"/>
-                      <a:tailEnd type="none" w="med" len="med"/>
-                    </a:lnB>
-                    <a:solidFill>
-                      <a:srgbClr val="F7F6F2"/>
-                    </a:solidFill>
-                  </a:tcPr>
-                </a:tc>
-                <a:extLst>
-                  <a:ext uri="{0D108BD9-81ED-4DB2-BD59-A6C34878D82A}">
-                    <a16:rowId xmlns:a16="http://schemas.microsoft.com/office/drawing/2014/main" val="2032191303"/>
-                  </a:ext>
-                </a:extLst>
-              </a:tr>
-            </a:tbl>
-          </a:graphicData>
-        </a:graphic>
-      </p:graphicFrame>
-      <p:sp>
-        <p:nvSpPr>
-          <p:cNvPr id="9" name="Next milestone: connect the three parts end to end">
-            <a:extLst>
-              <a:ext uri="{FF2B5EF4-FFF2-40B4-BE49-F238E27FC236}">
-                <a16:creationId xmlns:a16="http://schemas.microsoft.com/office/drawing/2014/main" id="{1B42776B-B02E-645E-06CE-586C6DCFB2D2}"/>
-              </a:ext>
-            </a:extLst>
-          </p:cNvPr>
-          <p:cNvSpPr txBox="1"/>
-          <p:nvPr/>
-        </p:nvSpPr>
-        <p:spPr>
-          <a:xfrm>
-            <a:off x="812800" y="4737099"/>
-            <a:ext cx="10566399" cy="698500"/>
-          </a:xfrm>
-          <a:prstGeom prst="rect">
-            <a:avLst/>
-          </a:prstGeom>
-          <a:noFill/>
-          <a:ln>
-            <a:noFill/>
-          </a:ln>
-        </p:spPr>
-        <p:txBody>
-          <a:bodyPr lIns="0" tIns="0" rIns="0" bIns="0" anchor="t">
-            <a:noAutofit/>
-          </a:bodyPr>
-          <a:lstStyle/>
-          <a:p>
-            <a:pPr lvl="0">
-              <a:lnSpc>
-                <a:spcPct val="140000"/>
-              </a:lnSpc>
-              <a:spcBef>
-                <a:spcPts val="0"/>
-              </a:spcBef>
-              <a:spcAft>
-                <a:spcPts val="0"/>
-              </a:spcAft>
-              <a:buNone/>
-              <a:defRPr sz="1400" b="0">
-                <a:solidFill>
-                  <a:srgbClr val="4A5568"/>
-                </a:solidFill>
-                <a:latin typeface="Arial"/>
-              </a:defRPr>
-            </a:pPr>
-            <a:r>
-              <a:rPr lang="en-US" sz="1400" b="0">
-                <a:solidFill>
-                  <a:srgbClr val="4A5568"/>
-                </a:solidFill>
-                <a:latin typeface="Arial"/>
-              </a:rPr>
-              <a:t>Next milestone: connect the three parts end to end, with a real model loop.</a:t>
-            </a:r>
-          </a:p>
-        </p:txBody>
-      </p:sp>
-    </p:spTree>
-  </p:cSld>
-  <p:clrMapOvr>
-    <a:masterClrMapping/>
-  </p:clrMapOvr>
-</p:sld>
+<file path=ppt/slides/slide3.xml><?xml version="1.0" encoding="UTF-8" standalone="yes"?>
+<p:sld xmlns:a="http://schemas.openxmlformats.org/drawingml/2006/main" xmlns:r="http://schemas.openxmlformats.org/officeDocument/2006/relationships" xmlns:p="http://schemas.openxmlformats.org/presentationml/2006/main"><p:cSld name="arch"><p:spTree><p:nvGrpSpPr><p:cNvPr id="1" name=""/><p:cNvGrpSpPr/><p:nvPr/></p:nvGrpSpPr><p:grpSpPr><a:xfrm><a:off x="0" y="0"/><a:ext cx="0" cy="0"/><a:chOff x="0" y="0"/><a:chExt cx="0" cy="0"/></a:xfrm></p:grpSpPr><p:sp><p:nvSpPr><p:cNvPr id="2" name="Background"><a:extLst><a:ext uri="{FF2B5EF4-FFF2-40B4-BE49-F238E27FC236}"><a16:creationId xmlns:a16="http://schemas.microsoft.com/office/drawing/2014/main" id="{C14C7F5C-0DB5-ABDD-3895-8EF4D0615D0C}"/></a:ext></a:extLst></p:cNvPr><p:cNvSpPr txBox="1"/><p:nvPr/></p:nvSpPr><p:spPr><a:xfrm><a:off x="0" y="0"/><a:ext cx="12192001" cy="6858000"/></a:xfrm><a:prstGeom prst="rect"><a:avLst/></a:prstGeom><a:solidFill><a:srgbClr val="F7F6F2"/></a:solidFill><a:ln><a:noFill/></a:ln></p:spPr><p:txBody><a:bodyPr lIns="0" tIns="0" rIns="0" bIns="0"/><a:lstStyle/><a:p><a:endParaRPr lang="en-US"/></a:p></p:txBody></p:sp><p:sp><p:nvSpPr><p:cNvPr id="3" name="ARCHITECTURE"><a:extLst><a:ext uri="{FF2B5EF4-FFF2-40B4-BE49-F238E27FC236}"><a16:creationId xmlns:a16="http://schemas.microsoft.com/office/drawing/2014/main" id="{6E8CED4E-396E-238B-3B51-F99A757A206D}"/></a:ext></a:extLst></p:cNvPr><p:cNvSpPr txBox="1"/><p:nvPr/></p:nvSpPr><p:spPr><a:xfrm><a:off x="812800" y="812800"/><a:ext cx="10566399" cy="254001"/></a:xfrm><a:prstGeom prst="rect"><a:avLst/></a:prstGeom><a:noFill/><a:ln><a:noFill/></a:ln></p:spPr><p:txBody><a:bodyPr lIns="0" tIns="0" rIns="0" bIns="0" anchor="t"><a:noAutofit/></a:bodyPr><a:lstStyle/><a:p><a:pPr lvl="0"><a:lnSpc><a:spcPct val="120000"/></a:lnSpc><a:spcBef><a:spcPts val="0"/></a:spcBef><a:spcAft><a:spcPts val="0"/></a:spcAft><a:buNone/><a:defRPr sz="1200" b="0"><a:solidFill><a:srgbClr val="B44E14"/></a:solidFill><a:latin typeface="Courier New"/></a:defRPr></a:pPr><a:r><a:rPr lang="en-US" sz="1200" b="0"><a:solidFill><a:srgbClr val="B44E14"/></a:solidFill><a:latin typeface="Courier New"/></a:rPr><a:t>ARCHITECTURE</a:t></a:r></a:p></p:txBody></p:sp><p:sp><p:nvSpPr><p:cNvPr id="4" name="Three parts, every step guarded"><a:extLst><a:ext uri="{FF2B5EF4-FFF2-40B4-BE49-F238E27FC236}"><a16:creationId xmlns:a16="http://schemas.microsoft.com/office/drawing/2014/main" id="{B90BEA9F-C1F6-2274-423E-D913BCAD32CA}"/></a:ext></a:extLst></p:cNvPr><p:cNvSpPr txBox="1"/><p:nvPr/></p:nvSpPr><p:spPr><a:xfrm><a:off x="812800" y="1143000"/><a:ext cx="10566399" cy="984250"/></a:xfrm><a:prstGeom prst="rect"><a:avLst/></a:prstGeom><a:noFill/><a:ln><a:noFill/></a:ln></p:spPr><p:txBody><a:bodyPr lIns="0" tIns="0" rIns="0" bIns="0" anchor="t"><a:noAutofit/></a:bodyPr><a:lstStyle/><a:p><a:pPr lvl="0"><a:lnSpc><a:spcPct val="110000"/></a:lnSpc><a:spcBef><a:spcPts val="0"/></a:spcBef><a:spcAft><a:spcPts val="0"/></a:spcAft><a:buNone/><a:defRPr sz="3200" b="1"><a:solidFill><a:srgbClr val="14213D"/></a:solidFill><a:latin typeface="Arial"/></a:defRPr></a:pPr><a:r><a:rPr lang="en-US" sz="3200" b="1"><a:solidFill><a:srgbClr val="14213D"/></a:solidFill><a:latin typeface="Arial"/></a:rPr><a:t>Three parts, every step guarded</a:t></a:r></a:p></p:txBody></p:sp><p:sp><p:nvSpPr><p:cNvPr id="5" name="Pharmacy-AGENT · Synthetic tests; human operationa"><a:extLst><a:ext uri="{FF2B5EF4-FFF2-40B4-BE49-F238E27FC236}"><a16:creationId xmlns:a16="http://schemas.microsoft.com/office/drawing/2014/main" id="{B44CA3A5-DF7C-B4B1-CF35-B39B47E231FF}"/></a:ext></a:extLst></p:cNvPr><p:cNvSpPr txBox="1"/><p:nvPr/></p:nvSpPr><p:spPr><a:xfrm><a:off x="812800" y="6222999"/><a:ext cx="10566399" cy="279399"/></a:xfrm><a:prstGeom prst="rect"><a:avLst/></a:prstGeom><a:noFill/><a:ln><a:noFill/></a:ln></p:spPr><p:txBody><a:bodyPr lIns="0" tIns="0" rIns="0" bIns="0" anchor="t"><a:noAutofit/></a:bodyPr><a:lstStyle/><a:p><a:pPr lvl="0"><a:lnSpc><a:spcPct val="120000"/></a:lnSpc><a:spcBef><a:spcPts val="0"/></a:spcBef><a:spcAft><a:spcPts val="0"/></a:spcAft><a:buNone/><a:defRPr sz="1200" b="0"><a:solidFill><a:srgbClr val="6A7385"/></a:solidFill><a:latin typeface="Arial"/></a:defRPr></a:pPr><a:r><a:rPr lang="en-US" sz="1200" b="0"><a:solidFill><a:srgbClr val="6A7385"/></a:solidFill><a:latin typeface="Arial"/></a:rPr><a:t>Pharmacy-AGENT · Synthetic tests; human operational decisions · 3 / 10</a:t></a:r></a:p></p:txBody></p:sp><p:sp><p:nvSpPr><p:cNvPr id="6" name="Background"><a:extLst><a:ext uri="{FF2B5EF4-FFF2-40B4-BE49-F238E27FC236}"><a16:creationId xmlns:a16="http://schemas.microsoft.com/office/drawing/2014/main" id="{78CB14F0-6999-E156-9039-E345A07641E6}"/></a:ext></a:extLst></p:cNvPr><p:cNvSpPr txBox="1"/><p:nvPr/></p:nvSpPr><p:spPr><a:xfrm><a:off x="812800" y="1854201"/><a:ext cx="10566399" cy="571500"/></a:xfrm><a:prstGeom prst="rect"><a:avLst/></a:prstGeom><a:solidFill><a:srgbClr val="E8EBF1"/></a:solidFill><a:ln><a:noFill/></a:ln></p:spPr><p:txBody><a:bodyPr lIns="0" tIns="0" rIns="0" bIns="0"/><a:lstStyle/><a:p><a:endParaRPr lang="en-US"/></a:p></p:txBody></p:sp><p:sp><p:nvSpPr><p:cNvPr id="7" name="Input → guarded reads → calculate & assemble"><a:extLst><a:ext uri="{FF2B5EF4-FFF2-40B4-BE49-F238E27FC236}"><a16:creationId xmlns:a16="http://schemas.microsoft.com/office/drawing/2014/main" id="{C0AB4FCF-4861-AD57-1148-6196C4DD1EBE}"/></a:ext></a:extLst></p:cNvPr><p:cNvSpPr txBox="1"/><p:nvPr/></p:nvSpPr><p:spPr><a:xfrm><a:off x="990601" y="2006600"/><a:ext cx="10210798" cy="380998"/></a:xfrm><a:prstGeom prst="rect"><a:avLst/></a:prstGeom><a:noFill/><a:ln><a:noFill/></a:ln></p:spPr><p:txBody><a:bodyPr lIns="0" tIns="0" rIns="0" bIns="0" anchor="t"><a:noAutofit/></a:bodyPr><a:lstStyle/><a:p><a:pPr lvl="0"><a:lnSpc><a:spcPct val="120000"/></a:lnSpc><a:spcBef><a:spcPts val="0"/></a:spcBef><a:spcAft><a:spcPts val="0"/></a:spcAft><a:buNone/><a:defRPr sz="1300" b="0"><a:solidFill><a:srgbClr val="14213D"/></a:solidFill><a:latin typeface="Courier New"/></a:defRPr></a:pPr><a:r><a:rPr lang="en-US" sz="1300" b="0"><a:solidFill><a:srgbClr val="14213D"/></a:solidFill><a:latin typeface="Courier New"/></a:rPr><a:t>Input → guarded reads → calculate & assemble → one model copy → validate → human</a:t></a:r></a:p></p:txBody></p:sp><p:graphicFrame><p:nvGraphicFramePr><p:cNvPr id="8" name="Table 7"><a:extLst><a:ext uri="{FF2B5EF4-FFF2-40B4-BE49-F238E27FC236}"><a16:creationId xmlns:a16="http://schemas.microsoft.com/office/drawing/2014/main" id="{8A47B976-AB0B-6087-E5C3-591297443A8E}"/></a:ext></a:extLst></p:cNvPr><p:cNvGraphicFramePr><a:graphicFrameLocks noGrp="1"/></p:cNvGraphicFramePr><p:nvPr/></p:nvGraphicFramePr><p:xfrm><a:off x="812800" y="2730499"/><a:ext cx="10566399" cy="1574798"/></p:xfrm><a:graphic><a:graphicData uri="http://schemas.openxmlformats.org/drawingml/2006/table"><a:tbl><a:tblPr/><a:tblGrid><a:gridCol w="2535937"><a:extLst><a:ext uri="{9D8B030D-6E8A-4147-A177-3AD203B41FA5}"><a16:colId xmlns:a16="http://schemas.microsoft.com/office/drawing/2014/main" val="1096448313"/></a:ext></a:extLst></a:gridCol><a:gridCol w="2535937"><a:extLst><a:ext uri="{9D8B030D-6E8A-4147-A177-3AD203B41FA5}"><a16:colId xmlns:a16="http://schemas.microsoft.com/office/drawing/2014/main" val="1922132533"/></a:ext></a:extLst></a:gridCol><a:gridCol w="5494528"><a:extLst><a:ext uri="{9D8B030D-6E8A-4147-A177-3AD203B41FA5}"><a16:colId xmlns:a16="http://schemas.microsoft.com/office/drawing/2014/main" val="3085363466"/></a:ext></a:extLst></a:gridCol></a:tblGrid><a:tr h="393699"><a:tc><a:txBody><a:bodyPr/><a:lstStyle/><a:p><a:pPr lvl="0"><a:lnSpc><a:spcPct val="125000"/></a:lnSpc><a:spcBef><a:spcPts val="0"/></a:spcBef><a:spcAft><a:spcPts val="0"/></a:spcAft><a:buNone/><a:defRPr sz="1300" b="1"><a:solidFill><a:srgbClr val="14213D"/></a:solidFill><a:latin typeface="Arial"/></a:defRPr></a:pPr><a:r><a:rPr lang="en-US" sz="1300" b="1"><a:solidFill><a:srgbClr val="14213D"/></a:solidFill><a:latin typeface="Arial"/></a:rPr><a:t>Component</a:t></a:r></a:p></a:txBody><a:tcPr><a:lnB w="7200" cap="flat" cmpd="sng" algn="ctr"><a:solidFill><a:srgbClr val="DCDFE5"/></a:solidFill><a:prstDash val="solid"/><a:round/><a:headEnd type="none" w="med" len="med"/><a:tailEnd type="none" w="med" len="med"/></a:lnB><a:solidFill><a:srgbClr val="F7F6F2"/></a:solidFill></a:tcPr></a:tc><a:tc><a:txBody><a:bodyPr/><a:lstStyle/><a:p><a:pPr lvl="0"><a:lnSpc><a:spcPct val="125000"/></a:lnSpc><a:spcBef><a:spcPts val="0"/></a:spcBef><a:spcAft><a:spcPts val="0"/></a:spcAft><a:buNone/><a:defRPr sz="1300" b="1"><a:solidFill><a:srgbClr val="14213D"/></a:solidFill><a:latin typeface="Arial"/></a:defRPr></a:pPr><a:r><a:rPr lang="en-US" sz="1300" b="1"><a:solidFill><a:srgbClr val="14213D"/></a:solidFill><a:latin typeface="Arial"/></a:rPr><a:t>Owner</a:t></a:r></a:p></a:txBody><a:tcPr><a:lnB w="7200" cap="flat" cmpd="sng" algn="ctr"><a:solidFill><a:srgbClr val="DCDFE5"/></a:solidFill><a:prstDash val="solid"/><a:round/><a:headEnd type="none" w="med" len="med"/><a:tailEnd type="none" w="med" len="med"/></a:lnB><a:solidFill><a:srgbClr val="F7F6F2"/></a:solidFill></a:tcPr></a:tc><a:tc><a:txBody><a:bodyPr/><a:lstStyle/><a:p><a:pPr lvl="0"><a:lnSpc><a:spcPct val="125000"/></a:lnSpc><a:spcBef><a:spcPts val="0"/></a:spcBef><a:spcAft><a:spcPts val="0"/></a:spcAft><a:buNone/><a:defRPr sz="1300" b="1"><a:solidFill><a:srgbClr val="14213D"/></a:solidFill><a:latin typeface="Arial"/></a:defRPr></a:pPr><a:r><a:rPr lang="en-US" sz="1300" b="1"><a:solidFill><a:srgbClr val="14213D"/></a:solidFill><a:latin typeface="Arial"/></a:rPr><a:t>Responsibility</a:t></a:r></a:p></a:txBody><a:tcPr><a:lnB w="7200" cap="flat" cmpd="sng" algn="ctr"><a:solidFill><a:srgbClr val="DCDFE5"/></a:solidFill><a:prstDash val="solid"/><a:round/><a:headEnd type="none" w="med" len="med"/><a:tailEnd type="none" w="med" len="med"/></a:lnB><a:solidFill><a:srgbClr val="F7F6F2"/></a:solidFill></a:tcPr></a:tc><a:extLst><a:ext uri="{0D108BD9-81ED-4DB2-BD59-A6C34878D82A}"><a16:rowId xmlns:a16="http://schemas.microsoft.com/office/drawing/2014/main" val="2096825301"/></a:ext></a:extLst></a:tr><a:tr h="393699"><a:tc><a:txBody><a:bodyPr/><a:lstStyle/><a:p><a:pPr lvl="0"><a:lnSpc><a:spcPct val="125000"/></a:lnSpc><a:spcBef><a:spcPts val="0"/></a:spcBef><a:spcAft><a:spcPts val="0"/></a:spcAft><a:buNone/><a:defRPr sz="1300" b="0"><a:solidFill><a:srgbClr val="14213D"/></a:solidFill><a:latin typeface="Arial"/></a:defRPr></a:pPr><a:r><a:rPr lang="en-US" sz="1300" b="0"><a:solidFill><a:srgbClr val="14213D"/></a:solidFill><a:latin typeface="Arial"/></a:rPr><a:t>Harness</a:t></a:r></a:p></a:txBody><a:tcPr><a:lnT w="7200" cap="flat" cmpd="sng" algn="ctr"><a:solidFill><a:srgbClr val="DCDFE5"/></a:solidFill><a:prstDash val="solid"/><a:round/><a:headEnd type="none" w="med" len="med"/><a:tailEnd type="none" w="med" len="med"/></a:lnT><a:lnB w="7200" cap="flat" cmpd="sng" algn="ctr"><a:solidFill><a:srgbClr val="DCDFE5"/></a:solidFill><a:prstDash val="solid"/><a:round/><a:headEnd type="none" w="med" len="med"/><a:tailEnd type="none" w="med" len="med"/></a:lnB><a:solidFill><a:srgbClr val="F7F6F2"/></a:solidFill></a:tcPr></a:tc><a:tc><a:txBody><a:bodyPr/><a:lstStyle/><a:p><a:pPr lvl="0"><a:lnSpc><a:spcPct val="125000"/></a:lnSpc><a:spcBef><a:spcPts val="0"/></a:spcBef><a:spcAft><a:spcPts val="0"/></a:spcAft><a:buNone/><a:defRPr sz="1300" b="0"><a:solidFill><a:srgbClr val="14213D"/></a:solidFill><a:latin typeface="Arial"/></a:defRPr></a:pPr><a:r><a:rPr lang="en-US" sz="1300" b="0"><a:solidFill><a:srgbClr val="14213D"/></a:solidFill><a:latin typeface="Arial"/></a:rPr><a:t>Kerrian Gordon</a:t></a:r></a:p></a:txBody><a:tcPr><a:lnT w="7200" cap="flat" cmpd="sng" algn="ctr"><a:solidFill><a:srgbClr val="DCDFE5"/></a:solidFill><a:prstDash val="solid"/><a:round/><a:headEnd type="none" w="med" len="med"/><a:tailEnd type="none" w="med" len="med"/></a:lnT><a:lnB w="7200" cap="flat" cmpd="sng" algn="ctr"><a:solidFill><a:srgbClr val="DCDFE5"/></a:solidFill><a:prstDash val="solid"/><a:round/><a:headEnd type="none" w="med" len="med"/><a:tailEnd type="none" w="med" len="med"/></a:lnB><a:solidFill><a:srgbClr val="F7F6F2"/></a:solidFill></a:tcPr></a:tc><a:tc><a:txBody><a:bodyPr/><a:lstStyle/><a:p><a:pPr lvl="0"><a:lnSpc><a:spcPct val="125000"/></a:lnSpc><a:spcBef><a:spcPts val="0"/></a:spcBef><a:spcAft><a:spcPts val="0"/></a:spcAft><a:buNone/><a:defRPr sz="1300" b="0"><a:solidFill><a:srgbClr val="14213D"/></a:solidFill><a:latin typeface="Arial"/></a:defRPr></a:pPr><a:r><a:rPr lang="en-US" sz="1300" b="0"><a:solidFill><a:srgbClr val="14213D"/></a:solidFill><a:latin typeface="Arial"/></a:rPr><a:t>Run the review loop: check evidence, calculate, optional model copy, stop at a human report</a:t></a:r></a:p></a:txBody><a:tcPr><a:lnT w="7200" cap="flat" cmpd="sng" algn="ctr"><a:solidFill><a:srgbClr val="DCDFE5"/></a:solidFill><a:prstDash val="solid"/><a:round/><a:headEnd type="none" w="med" len="med"/><a:tailEnd type="none" w="med" len="med"/></a:lnT><a:lnB w="7200" cap="flat" cmpd="sng" algn="ctr"><a:solidFill><a:srgbClr val="DCDFE5"/></a:solidFill><a:prstDash val="solid"/><a:round/><a:headEnd type="none" w="med" len="med"/><a:tailEnd type="none" w="med" len="med"/></a:lnB><a:solidFill><a:srgbClr val="F7F6F2"/></a:solidFill></a:tcPr></a:tc><a:extLst><a:ext uri="{0D108BD9-81ED-4DB2-BD59-A6C34878D82A}"><a16:rowId xmlns:a16="http://schemas.microsoft.com/office/drawing/2014/main" val="2001623680"/></a:ext></a:extLst></a:tr><a:tr h="393699"><a:tc><a:txBody><a:bodyPr/><a:lstStyle/><a:p><a:pPr lvl="0"><a:lnSpc><a:spcPct val="125000"/></a:lnSpc><a:spcBef><a:spcPts val="0"/></a:spcBef><a:spcAft><a:spcPts val="0"/></a:spcAft><a:buNone/><a:defRPr sz="1300" b="0"><a:solidFill><a:srgbClr val="14213D"/></a:solidFill><a:latin typeface="Arial"/></a:defRPr></a:pPr><a:r><a:rPr lang="en-US" sz="1300" b="0"><a:solidFill><a:srgbClr val="14213D"/></a:solidFill><a:latin typeface="Arial"/></a:rPr><a:t>Tools + instructions</a:t></a:r></a:p></a:txBody><a:tcPr><a:lnT w="7200" cap="flat" cmpd="sng" algn="ctr"><a:solidFill><a:srgbClr val="DCDFE5"/></a:solidFill><a:prstDash val="solid"/><a:round/><a:headEnd type="none" w="med" len="med"/><a:tailEnd type="none" w="med" len="med"/></a:lnT><a:lnB w="7200" cap="flat" cmpd="sng" algn="ctr"><a:solidFill><a:srgbClr val="DCDFE5"/></a:solidFill><a:prstDash val="solid"/><a:round/><a:headEnd type="none" w="med" len="med"/><a:tailEnd type="none" w="med" len="med"/></a:lnB><a:solidFill><a:srgbClr val="F7F6F2"/></a:solidFill></a:tcPr></a:tc><a:tc><a:txBody><a:bodyPr/><a:lstStyle/><a:p><a:pPr lvl="0"><a:lnSpc><a:spcPct val="125000"/></a:lnSpc><a:spcBef><a:spcPts val="0"/></a:spcBef><a:spcAft><a:spcPts val="0"/></a:spcAft><a:buNone/><a:defRPr sz="1300" b="0"><a:solidFill><a:srgbClr val="14213D"/></a:solidFill><a:latin typeface="Arial"/></a:defRPr></a:pPr><a:r><a:rPr lang="en-US" sz="1300" b="0"><a:solidFill><a:srgbClr val="14213D"/></a:solidFill><a:latin typeface="Arial"/></a:rPr><a:t>Brahim Maouloud</a:t></a:r></a:p></a:txBody><a:tcPr><a:lnT w="7200" cap="flat" cmpd="sng" algn="ctr"><a:solidFill><a:srgbClr val="DCDFE5"/></a:solidFill><a:prstDash val="solid"/><a:round/><a:headEnd type="none" w="med" len="med"/><a:tailEnd type="none" w="med" len="med"/></a:lnT><a:lnB w="7200" cap="flat" cmpd="sng" algn="ctr"><a:solidFill><a:srgbClr val="DCDFE5"/></a:solidFill><a:prstDash val="solid"/><a:round/><a:headEnd type="none" w="med" len="med"/><a:tailEnd type="none" w="med" len="med"/></a:lnB><a:solidFill><a:srgbClr val="F7F6F2"/></a:solidFill></a:tcPr></a:tc><a:tc><a:txBody><a:bodyPr/><a:lstStyle/><a:p><a:pPr lvl="0"><a:lnSpc><a:spcPct val="125000"/></a:lnSpc><a:spcBef><a:spcPts val="0"/></a:spcBef><a:spcAft><a:spcPts val="0"/></a:spcAft><a:buNone/><a:defRPr sz="1300" b="0"><a:solidFill><a:srgbClr val="14213D"/></a:solidFill><a:latin typeface="Arial"/></a:defRPr></a:pPr><a:r><a:rPr lang="en-US" sz="1300" b="0"><a:solidFill><a:srgbClr val="14213D"/></a:solidFill><a:latin typeface="Arial"/></a:rPr><a:t>Inventory reader, FDA adapter, system prompt</a:t></a:r></a:p></a:txBody><a:tcPr><a:lnT w="7200" cap="flat" cmpd="sng" algn="ctr"><a:solidFill><a:srgbClr val="DCDFE5"/></a:solidFill><a:prstDash val="solid"/><a:round/><a:headEnd type="none" w="med" len="med"/><a:tailEnd type="none" w="med" len="med"/></a:lnT><a:lnB w="7200" cap="flat" cmpd="sng" algn="ctr"><a:solidFill><a:srgbClr val="DCDFE5"/></a:solidFill><a:prstDash val="solid"/><a:round/><a:headEnd type="none" w="med" len="med"/><a:tailEnd type="none" w="med" len="med"/></a:lnB><a:solidFill><a:srgbClr val="F7F6F2"/></a:solidFill></a:tcPr></a:tc><a:extLst><a:ext uri="{0D108BD9-81ED-4DB2-BD59-A6C34878D82A}"><a16:rowId xmlns:a16="http://schemas.microsoft.com/office/drawing/2014/main" val="2477041316"/></a:ext></a:extLst></a:tr><a:tr h="393699"><a:tc><a:txBody><a:bodyPr/><a:lstStyle/><a:p><a:pPr lvl="0"><a:lnSpc><a:spcPct val="125000"/></a:lnSpc><a:spcBef><a:spcPts val="0"/></a:spcBef><a:spcAft><a:spcPts val="0"/></a:spcAft><a:buNone/><a:defRPr sz="1300" b="0"><a:solidFill><a:srgbClr val="14213D"/></a:solidFill><a:latin typeface="Arial"/></a:defRPr></a:pPr><a:r><a:rPr lang="en-US" sz="1300" b="0"><a:solidFill><a:srgbClr val="14213D"/></a:solidFill><a:latin typeface="Arial"/></a:rPr><a:t>Prevention</a:t></a:r></a:p></a:txBody><a:tcPr><a:lnT w="7200" cap="flat" cmpd="sng" algn="ctr"><a:solidFill><a:srgbClr val="DCDFE5"/></a:solidFill><a:prstDash val="solid"/><a:round/><a:headEnd type="none" w="med" len="med"/><a:tailEnd type="none" w="med" len="med"/></a:lnT><a:lnB w="7200" cap="flat" cmpd="sng" algn="ctr"><a:solidFill><a:srgbClr val="DCDFE5"/></a:solidFill><a:prstDash val="solid"/><a:round/><a:headEnd type="none" w="med" len="med"/><a:tailEnd type="none" w="med" len="med"/></a:lnB><a:solidFill><a:srgbClr val="F7F6F2"/></a:solidFill></a:tcPr></a:tc><a:tc><a:txBody><a:bodyPr/><a:lstStyle/><a:p><a:pPr lvl="0"><a:lnSpc><a:spcPct val="125000"/></a:lnSpc><a:spcBef><a:spcPts val="0"/></a:spcBef><a:spcAft><a:spcPts val="0"/></a:spcAft><a:buNone/><a:defRPr sz="1300" b="0"><a:solidFill><a:srgbClr val="14213D"/></a:solidFill><a:latin typeface="Arial"/></a:defRPr></a:pPr><a:r><a:rPr lang="en-US" sz="1300" b="0"><a:solidFill><a:srgbClr val="14213D"/></a:solidFill><a:latin typeface="Arial"/></a:rPr><a:t>Emmanuel De Jesus</a:t></a:r></a:p></a:txBody><a:tcPr><a:lnT w="7200" cap="flat" cmpd="sng" algn="ctr"><a:solidFill><a:srgbClr val="DCDFE5"/></a:solidFill><a:prstDash val="solid"/><a:round/><a:headEnd type="none" w="med" len="med"/><a:tailEnd type="none" w="med" len="med"/></a:lnT><a:lnB w="7200" cap="flat" cmpd="sng" algn="ctr"><a:solidFill><a:srgbClr val="DCDFE5"/></a:solidFill><a:prstDash val="solid"/><a:round/><a:headEnd type="none" w="med" len="med"/><a:tailEnd type="none" w="med" len="med"/></a:lnB><a:solidFill><a:srgbClr val="F7F6F2"/></a:solidFill></a:tcPr></a:tc><a:tc><a:txBody><a:bodyPr/><a:lstStyle/><a:p><a:pPr lvl="0"><a:lnSpc><a:spcPct val="125000"/></a:lnSpc><a:spcBef><a:spcPts val="0"/></a:spcBef><a:spcAft><a:spcPts val="0"/></a:spcAft><a:buNone/><a:defRPr sz="1300" b="0"><a:solidFill><a:srgbClr val="14213D"/></a:solidFill><a:latin typeface="Arial"/></a:defRPr></a:pPr><a:r><a:rPr lang="en-US" sz="1300" b="0"><a:solidFill><a:srgbClr val="14213D"/></a:solidFill><a:latin typeface="Arial"/></a:rPr><a:t>Isolate context; enforce action and output contracts</a:t></a:r></a:p></a:txBody><a:tcPr><a:lnT w="7200" cap="flat" cmpd="sng" algn="ctr"><a:solidFill><a:srgbClr val="DCDFE5"/></a:solidFill><a:prstDash val="solid"/><a:round/><a:headEnd type="none" w="med" len="med"/><a:tailEnd type="none" w="med" len="med"/></a:lnT><a:lnB w="7200" cap="flat" cmpd="sng" algn="ctr"><a:solidFill><a:srgbClr val="DCDFE5"/></a:solidFill><a:prstDash val="solid"/><a:round/><a:headEnd type="none" w="med" len="med"/><a:tailEnd type="none" w="med" len="med"/></a:lnB><a:solidFill><a:srgbClr val="F7F6F2"/></a:solidFill></a:tcPr></a:tc><a:extLst><a:ext uri="{0D108BD9-81ED-4DB2-BD59-A6C34878D82A}"><a16:rowId xmlns:a16="http://schemas.microsoft.com/office/drawing/2014/main" val="2032191303"/></a:ext></a:extLst></a:tr></a:tbl></a:graphicData></a:graphic></p:graphicFrame><p:sp><p:nvSpPr><p:cNvPr id="9" name="Harness loop is live on synthetic data"><a:extLst><a:ext uri="{FF2B5EF4-FFF2-40B4-BE49-F238E27FC236}"><a16:creationId xmlns:a16="http://schemas.microsoft.com/office/drawing/2014/main" id="{1B42776B-B02E-645E-06CE-586C6DCFB2D2}"/></a:ext></a:extLst></p:cNvPr><p:cNvSpPr txBox="1"/><p:nvPr/></p:nvSpPr><p:spPr><a:xfrm><a:off x="812800" y="4737099"/><a:ext cx="10566399" cy="698500"/></a:xfrm><a:prstGeom prst="rect"><a:avLst/></a:prstGeom><a:noFill/><a:ln><a:noFill/></a:ln></p:spPr><p:txBody><a:bodyPr lIns="0" tIns="0" rIns="0" bIns="0" anchor="t"><a:noAutofit/></a:bodyPr><a:lstStyle/><a:p><a:pPr lvl="0"><a:lnSpc><a:spcPct val="140000"/></a:lnSpc><a:spcBef><a:spcPts val="0"/></a:spcBef><a:spcAft><a:spcPts val="0"/></a:spcAft><a:buNone/><a:defRPr sz="1400" b="0"><a:solidFill><a:srgbClr val="4A5568"/></a:solidFill><a:latin typeface="Arial"/></a:defRPr></a:pPr><a:r><a:rPr lang="en-US" sz="1400" b="0"><a:solidFill><a:srgbClr val="4A5568"/></a:solidFill><a:latin typeface="Arial"/></a:rPr><a:t>Harness loop is live on synthetic data: it starts on a review run, checkpoints at each guard, and stops when the human report is ready (or the model answer is rejected / unavailable).</a:t></a:r></a:p></p:txBody></p:sp></p:spTree></p:cSld><p:clrMapOvr><a:masterClrMapping/></p:clrMapOvr></p:sld>
 </file>
 
 <file path=ppt/slides/slide4.xml><?xml version="1.0" encoding="utf-8"?>
@@ -8775,7 +7633,7 @@
       </p:sp>
       <p:sp>
         <p:nvSpPr>
-          <p:cNvPr id="3" name="BRAHIM · SYSTEM PROMPT INSTRUCTIONS-V1">
+          <p:cNvPr id="3" name="BRAHIM · SYSTEM PROMPT INSTRUCTIONS-V2">
             <a:extLst>
               <a:ext uri="{FF2B5EF4-FFF2-40B4-BE49-F238E27FC236}">
                 <a16:creationId xmlns:a16="http://schemas.microsoft.com/office/drawing/2014/main" id="{5383C847-EE54-5951-DC31-DD713E0B14A7}"/>
@@ -8829,7 +7687,7 @@
                 </a:solidFill>
                 <a:latin typeface="Courier New"/>
               </a:rPr>
-              <a:t>BRAHIM · SYSTEM PROMPT INSTRUCTIONS-V1</a:t>
+              <a:t>BRAHIM · SYSTEM PROMPT INSTRUCTIONS-V2</a:t>
             </a:r>
           </a:p>
         </p:txBody>
@@ -11834,7 +10692,7 @@
                 </a:solidFill>
                 <a:latin typeface="Arial"/>
               </a:rPr>
-              <a:t>A passing fixture is not proof that every future attack will be detected.</a:t>
+              <a:t>A passing fixture is not proof that every future attack will be detected. These evals test code and guards. Live hostile text against a model is still untested; the design keeps untrusted free text out of the model's context.</a:t>
             </a:r>
           </a:p>
         </p:txBody>
@@ -11962,7 +10820,7 @@
       </p:sp>
       <p:sp>
         <p:nvSpPr>
-          <p:cNvPr id="4" name="Tested parts, ready to connect">
+          <p:cNvPr id="4" name="Connected on synthetic data — here is the loop">
             <a:extLst>
               <a:ext uri="{FF2B5EF4-FFF2-40B4-BE49-F238E27FC236}">
                 <a16:creationId xmlns:a16="http://schemas.microsoft.com/office/drawing/2014/main" id="{CBE87DD7-BB97-4A78-2A76-01C042573195}"/>
@@ -12016,7 +10874,7 @@
                 </a:solidFill>
                 <a:latin typeface="Arial"/>
               </a:rPr>
-              <a:t>Tested parts, ready to connect</a:t>
+              <a:t>Connected on synthetic data — here is the loop</a:t>
             </a:r>
           </a:p>
         </p:txBody>
@@ -12555,7 +11413,7 @@
       </p:sp>
       <p:sp>
         <p:nvSpPr>
-          <p:cNvPr id="15" name="01 Connect harness facts, read tools and guards; t">
+          <p:cNvPr id="15" name="Starts When a review run begins">
             <a:extLst>
               <a:ext uri="{FF2B5EF4-FFF2-40B4-BE49-F238E27FC236}">
                 <a16:creationId xmlns:a16="http://schemas.microsoft.com/office/drawing/2014/main" id="{34235828-090F-8673-9F4F-9E3234F8B8D8}"/>
@@ -12609,14 +11467,14 @@
                 </a:solidFill>
                 <a:latin typeface="Arial"/>
               </a:rPr>
-              <a:t>01 Connect harness facts, read tools and guards; test the model loop</a:t>
-            </a:r>
-          </a:p>
-        </p:txBody>
-      </p:sp>
-      <p:sp>
-        <p:nvSpPr>
-          <p:cNvPr id="16" name="02 Run the three Eval Card cases end to end">
+              <a:t>Starts When a review run begins on the synthetic store snapshot</a:t>
+            </a:r>
+          </a:p>
+        </p:txBody>
+      </p:sp>
+      <p:sp>
+        <p:nvSpPr>
+          <p:cNvPr id="16" name="Checkpoints Guarded reads → independent calculate → optional one model copy → output check. Stops Human report ready — or model rejected / unavailable, with verified facts still shown.">
             <a:extLst>
               <a:ext uri="{FF2B5EF4-FFF2-40B4-BE49-F238E27FC236}">
                 <a16:creationId xmlns:a16="http://schemas.microsoft.com/office/drawing/2014/main" id="{11C30F5C-61E9-50A2-0198-367C3653C4DC}"/>
@@ -12670,7 +11528,7 @@
                 </a:solidFill>
                 <a:latin typeface="Arial"/>
               </a:rPr>
-              <a:t>02 Run the three Eval Card cases end to end</a:t>
+              <a:t>Checkpoints Guarded reads → independent calculate → optional one model copy → output check. Stops Human report ready — or model rejected / unavailable, with verified facts still shown.</a:t>
             </a:r>
           </a:p>
         </p:txBody>

</xml_diff>

<commit_message>
fix(presentation): escape ampersands in team PowerPoint XML
Rebuild from the pre-edit backup so slide 3 parses; an unescaped & made PowerPoint repair-and-remove content.
</commit_message>
<xml_diff>
--- a/docs/presentations/Pharmacy-Agent-Team-Presentation.pptx
+++ b/docs/presentations/Pharmacy-Agent-Team-Presentation.pptx
@@ -403,7 +403,7 @@
                 </a:solidFill>
                 <a:latin typeface="Arial"/>
               </a:rPr>
-              <a:t>Pour conclure, en trois points. Ce que nous avons construit : deux outils en lecture seule, un prompt système strict, cinq contrôles contre l'injection, et une boucle de revue du harnais avec un tour de modèle gardé, tous testés sur des données synthétiques. Ce que nous avons appris : il faut tester les outils pour de vrai ; une panne ou une absence de résultat ne veut jamais dire "pas de pénurie" ; et les règles de sécurité doivent être dans le code, pas seulement dans le prompt. La suite : faire évoluer le parcours de démo visible, et n'utiliser de vraies données pharmacie qu'après approbation. Le harnais avec un tour de modèle gardé est déjà connecté sur des données synthétiques. Merci ! Avez-vous des questions ?</a:t>
+              <a:t>Pour conclure, en trois points. Ce que nous avons construit : deux outils en lecture seule, un prompt système strict, cinq contrôles contre l'injection, et une boucle de revue du harnais — dont une copie modèle gardée — sur données synthétiques. Ce que nous avons appris : tester les outils pour de vrai ; un timeout n'est jamais « pas de pénurie » ; les règles de sécurité vivent dans le code. Ensuite : améliorer le chemin de démo visible ; données pharmacie live seulement après approbation. Le chemin modèle du harnais est déjà connecté sur synthétique.</a:t>
             </a:r>
           </a:p>
         </p:txBody>
@@ -4311,7 +4311,7 @@
       </p:sp>
       <p:sp>
         <p:nvSpPr>
-          <p:cNvPr id="8" name="Two read-only tools, prompt, controls, harness loop">
+          <p:cNvPr id="8" name="Two read-only tools, a strict system prompt and fi">
             <a:extLst>
               <a:ext uri="{FF2B5EF4-FFF2-40B4-BE49-F238E27FC236}">
                 <a16:creationId xmlns:a16="http://schemas.microsoft.com/office/drawing/2014/main" id="{8C6B2376-E699-4B52-A9EB-FAA254188536}"/>
@@ -4625,7 +4625,7 @@
       </p:sp>
       <p:sp>
         <p:nvSpPr>
-          <p:cNvPr id="14" name="Keep improving the demo path">
+          <p:cNvPr id="14" name="Connect the harness, run the Eval Card end to end,">
             <a:extLst>
               <a:ext uri="{FF2B5EF4-FFF2-40B4-BE49-F238E27FC236}">
                 <a16:creationId xmlns:a16="http://schemas.microsoft.com/office/drawing/2014/main" id="{B4F1C483-61B8-6E7E-052E-987BECAE4267}"/>
@@ -5999,8 +5999,1150 @@
 </p:sld>
 </file>
 
-<file path=ppt/slides/slide3.xml><?xml version="1.0" encoding="UTF-8" standalone="yes"?>
-<p:sld xmlns:a="http://schemas.openxmlformats.org/drawingml/2006/main" xmlns:r="http://schemas.openxmlformats.org/officeDocument/2006/relationships" xmlns:p="http://schemas.openxmlformats.org/presentationml/2006/main"><p:cSld name="arch"><p:spTree><p:nvGrpSpPr><p:cNvPr id="1" name=""/><p:cNvGrpSpPr/><p:nvPr/></p:nvGrpSpPr><p:grpSpPr><a:xfrm><a:off x="0" y="0"/><a:ext cx="0" cy="0"/><a:chOff x="0" y="0"/><a:chExt cx="0" cy="0"/></a:xfrm></p:grpSpPr><p:sp><p:nvSpPr><p:cNvPr id="2" name="Background"><a:extLst><a:ext uri="{FF2B5EF4-FFF2-40B4-BE49-F238E27FC236}"><a16:creationId xmlns:a16="http://schemas.microsoft.com/office/drawing/2014/main" id="{C14C7F5C-0DB5-ABDD-3895-8EF4D0615D0C}"/></a:ext></a:extLst></p:cNvPr><p:cNvSpPr txBox="1"/><p:nvPr/></p:nvSpPr><p:spPr><a:xfrm><a:off x="0" y="0"/><a:ext cx="12192001" cy="6858000"/></a:xfrm><a:prstGeom prst="rect"><a:avLst/></a:prstGeom><a:solidFill><a:srgbClr val="F7F6F2"/></a:solidFill><a:ln><a:noFill/></a:ln></p:spPr><p:txBody><a:bodyPr lIns="0" tIns="0" rIns="0" bIns="0"/><a:lstStyle/><a:p><a:endParaRPr lang="en-US"/></a:p></p:txBody></p:sp><p:sp><p:nvSpPr><p:cNvPr id="3" name="ARCHITECTURE"><a:extLst><a:ext uri="{FF2B5EF4-FFF2-40B4-BE49-F238E27FC236}"><a16:creationId xmlns:a16="http://schemas.microsoft.com/office/drawing/2014/main" id="{6E8CED4E-396E-238B-3B51-F99A757A206D}"/></a:ext></a:extLst></p:cNvPr><p:cNvSpPr txBox="1"/><p:nvPr/></p:nvSpPr><p:spPr><a:xfrm><a:off x="812800" y="812800"/><a:ext cx="10566399" cy="254001"/></a:xfrm><a:prstGeom prst="rect"><a:avLst/></a:prstGeom><a:noFill/><a:ln><a:noFill/></a:ln></p:spPr><p:txBody><a:bodyPr lIns="0" tIns="0" rIns="0" bIns="0" anchor="t"><a:noAutofit/></a:bodyPr><a:lstStyle/><a:p><a:pPr lvl="0"><a:lnSpc><a:spcPct val="120000"/></a:lnSpc><a:spcBef><a:spcPts val="0"/></a:spcBef><a:spcAft><a:spcPts val="0"/></a:spcAft><a:buNone/><a:defRPr sz="1200" b="0"><a:solidFill><a:srgbClr val="B44E14"/></a:solidFill><a:latin typeface="Courier New"/></a:defRPr></a:pPr><a:r><a:rPr lang="en-US" sz="1200" b="0"><a:solidFill><a:srgbClr val="B44E14"/></a:solidFill><a:latin typeface="Courier New"/></a:rPr><a:t>ARCHITECTURE</a:t></a:r></a:p></p:txBody></p:sp><p:sp><p:nvSpPr><p:cNvPr id="4" name="Three parts, every step guarded"><a:extLst><a:ext uri="{FF2B5EF4-FFF2-40B4-BE49-F238E27FC236}"><a16:creationId xmlns:a16="http://schemas.microsoft.com/office/drawing/2014/main" id="{B90BEA9F-C1F6-2274-423E-D913BCAD32CA}"/></a:ext></a:extLst></p:cNvPr><p:cNvSpPr txBox="1"/><p:nvPr/></p:nvSpPr><p:spPr><a:xfrm><a:off x="812800" y="1143000"/><a:ext cx="10566399" cy="984250"/></a:xfrm><a:prstGeom prst="rect"><a:avLst/></a:prstGeom><a:noFill/><a:ln><a:noFill/></a:ln></p:spPr><p:txBody><a:bodyPr lIns="0" tIns="0" rIns="0" bIns="0" anchor="t"><a:noAutofit/></a:bodyPr><a:lstStyle/><a:p><a:pPr lvl="0"><a:lnSpc><a:spcPct val="110000"/></a:lnSpc><a:spcBef><a:spcPts val="0"/></a:spcBef><a:spcAft><a:spcPts val="0"/></a:spcAft><a:buNone/><a:defRPr sz="3200" b="1"><a:solidFill><a:srgbClr val="14213D"/></a:solidFill><a:latin typeface="Arial"/></a:defRPr></a:pPr><a:r><a:rPr lang="en-US" sz="3200" b="1"><a:solidFill><a:srgbClr val="14213D"/></a:solidFill><a:latin typeface="Arial"/></a:rPr><a:t>Three parts, every step guarded</a:t></a:r></a:p></p:txBody></p:sp><p:sp><p:nvSpPr><p:cNvPr id="5" name="Pharmacy-AGENT · Synthetic tests; human operationa"><a:extLst><a:ext uri="{FF2B5EF4-FFF2-40B4-BE49-F238E27FC236}"><a16:creationId xmlns:a16="http://schemas.microsoft.com/office/drawing/2014/main" id="{B44CA3A5-DF7C-B4B1-CF35-B39B47E231FF}"/></a:ext></a:extLst></p:cNvPr><p:cNvSpPr txBox="1"/><p:nvPr/></p:nvSpPr><p:spPr><a:xfrm><a:off x="812800" y="6222999"/><a:ext cx="10566399" cy="279399"/></a:xfrm><a:prstGeom prst="rect"><a:avLst/></a:prstGeom><a:noFill/><a:ln><a:noFill/></a:ln></p:spPr><p:txBody><a:bodyPr lIns="0" tIns="0" rIns="0" bIns="0" anchor="t"><a:noAutofit/></a:bodyPr><a:lstStyle/><a:p><a:pPr lvl="0"><a:lnSpc><a:spcPct val="120000"/></a:lnSpc><a:spcBef><a:spcPts val="0"/></a:spcBef><a:spcAft><a:spcPts val="0"/></a:spcAft><a:buNone/><a:defRPr sz="1200" b="0"><a:solidFill><a:srgbClr val="6A7385"/></a:solidFill><a:latin typeface="Arial"/></a:defRPr></a:pPr><a:r><a:rPr lang="en-US" sz="1200" b="0"><a:solidFill><a:srgbClr val="6A7385"/></a:solidFill><a:latin typeface="Arial"/></a:rPr><a:t>Pharmacy-AGENT · Synthetic tests; human operational decisions · 3 / 10</a:t></a:r></a:p></p:txBody></p:sp><p:sp><p:nvSpPr><p:cNvPr id="6" name="Background"><a:extLst><a:ext uri="{FF2B5EF4-FFF2-40B4-BE49-F238E27FC236}"><a16:creationId xmlns:a16="http://schemas.microsoft.com/office/drawing/2014/main" id="{78CB14F0-6999-E156-9039-E345A07641E6}"/></a:ext></a:extLst></p:cNvPr><p:cNvSpPr txBox="1"/><p:nvPr/></p:nvSpPr><p:spPr><a:xfrm><a:off x="812800" y="1854201"/><a:ext cx="10566399" cy="571500"/></a:xfrm><a:prstGeom prst="rect"><a:avLst/></a:prstGeom><a:solidFill><a:srgbClr val="E8EBF1"/></a:solidFill><a:ln><a:noFill/></a:ln></p:spPr><p:txBody><a:bodyPr lIns="0" tIns="0" rIns="0" bIns="0"/><a:lstStyle/><a:p><a:endParaRPr lang="en-US"/></a:p></p:txBody></p:sp><p:sp><p:nvSpPr><p:cNvPr id="7" name="Input → guarded reads → calculate & assemble"><a:extLst><a:ext uri="{FF2B5EF4-FFF2-40B4-BE49-F238E27FC236}"><a16:creationId xmlns:a16="http://schemas.microsoft.com/office/drawing/2014/main" id="{C0AB4FCF-4861-AD57-1148-6196C4DD1EBE}"/></a:ext></a:extLst></p:cNvPr><p:cNvSpPr txBox="1"/><p:nvPr/></p:nvSpPr><p:spPr><a:xfrm><a:off x="990601" y="2006600"/><a:ext cx="10210798" cy="380998"/></a:xfrm><a:prstGeom prst="rect"><a:avLst/></a:prstGeom><a:noFill/><a:ln><a:noFill/></a:ln></p:spPr><p:txBody><a:bodyPr lIns="0" tIns="0" rIns="0" bIns="0" anchor="t"><a:noAutofit/></a:bodyPr><a:lstStyle/><a:p><a:pPr lvl="0"><a:lnSpc><a:spcPct val="120000"/></a:lnSpc><a:spcBef><a:spcPts val="0"/></a:spcBef><a:spcAft><a:spcPts val="0"/></a:spcAft><a:buNone/><a:defRPr sz="1300" b="0"><a:solidFill><a:srgbClr val="14213D"/></a:solidFill><a:latin typeface="Courier New"/></a:defRPr></a:pPr><a:r><a:rPr lang="en-US" sz="1300" b="0"><a:solidFill><a:srgbClr val="14213D"/></a:solidFill><a:latin typeface="Courier New"/></a:rPr><a:t>Input → guarded reads → calculate & assemble → one model copy → validate → human</a:t></a:r></a:p></p:txBody></p:sp><p:graphicFrame><p:nvGraphicFramePr><p:cNvPr id="8" name="Table 7"><a:extLst><a:ext uri="{FF2B5EF4-FFF2-40B4-BE49-F238E27FC236}"><a16:creationId xmlns:a16="http://schemas.microsoft.com/office/drawing/2014/main" id="{8A47B976-AB0B-6087-E5C3-591297443A8E}"/></a:ext></a:extLst></p:cNvPr><p:cNvGraphicFramePr><a:graphicFrameLocks noGrp="1"/></p:cNvGraphicFramePr><p:nvPr/></p:nvGraphicFramePr><p:xfrm><a:off x="812800" y="2730499"/><a:ext cx="10566399" cy="1574798"/></p:xfrm><a:graphic><a:graphicData uri="http://schemas.openxmlformats.org/drawingml/2006/table"><a:tbl><a:tblPr/><a:tblGrid><a:gridCol w="2535937"><a:extLst><a:ext uri="{9D8B030D-6E8A-4147-A177-3AD203B41FA5}"><a16:colId xmlns:a16="http://schemas.microsoft.com/office/drawing/2014/main" val="1096448313"/></a:ext></a:extLst></a:gridCol><a:gridCol w="2535937"><a:extLst><a:ext uri="{9D8B030D-6E8A-4147-A177-3AD203B41FA5}"><a16:colId xmlns:a16="http://schemas.microsoft.com/office/drawing/2014/main" val="1922132533"/></a:ext></a:extLst></a:gridCol><a:gridCol w="5494528"><a:extLst><a:ext uri="{9D8B030D-6E8A-4147-A177-3AD203B41FA5}"><a16:colId xmlns:a16="http://schemas.microsoft.com/office/drawing/2014/main" val="3085363466"/></a:ext></a:extLst></a:gridCol></a:tblGrid><a:tr h="393699"><a:tc><a:txBody><a:bodyPr/><a:lstStyle/><a:p><a:pPr lvl="0"><a:lnSpc><a:spcPct val="125000"/></a:lnSpc><a:spcBef><a:spcPts val="0"/></a:spcBef><a:spcAft><a:spcPts val="0"/></a:spcAft><a:buNone/><a:defRPr sz="1300" b="1"><a:solidFill><a:srgbClr val="14213D"/></a:solidFill><a:latin typeface="Arial"/></a:defRPr></a:pPr><a:r><a:rPr lang="en-US" sz="1300" b="1"><a:solidFill><a:srgbClr val="14213D"/></a:solidFill><a:latin typeface="Arial"/></a:rPr><a:t>Component</a:t></a:r></a:p></a:txBody><a:tcPr><a:lnB w="7200" cap="flat" cmpd="sng" algn="ctr"><a:solidFill><a:srgbClr val="DCDFE5"/></a:solidFill><a:prstDash val="solid"/><a:round/><a:headEnd type="none" w="med" len="med"/><a:tailEnd type="none" w="med" len="med"/></a:lnB><a:solidFill><a:srgbClr val="F7F6F2"/></a:solidFill></a:tcPr></a:tc><a:tc><a:txBody><a:bodyPr/><a:lstStyle/><a:p><a:pPr lvl="0"><a:lnSpc><a:spcPct val="125000"/></a:lnSpc><a:spcBef><a:spcPts val="0"/></a:spcBef><a:spcAft><a:spcPts val="0"/></a:spcAft><a:buNone/><a:defRPr sz="1300" b="1"><a:solidFill><a:srgbClr val="14213D"/></a:solidFill><a:latin typeface="Arial"/></a:defRPr></a:pPr><a:r><a:rPr lang="en-US" sz="1300" b="1"><a:solidFill><a:srgbClr val="14213D"/></a:solidFill><a:latin typeface="Arial"/></a:rPr><a:t>Owner</a:t></a:r></a:p></a:txBody><a:tcPr><a:lnB w="7200" cap="flat" cmpd="sng" algn="ctr"><a:solidFill><a:srgbClr val="DCDFE5"/></a:solidFill><a:prstDash val="solid"/><a:round/><a:headEnd type="none" w="med" len="med"/><a:tailEnd type="none" w="med" len="med"/></a:lnB><a:solidFill><a:srgbClr val="F7F6F2"/></a:solidFill></a:tcPr></a:tc><a:tc><a:txBody><a:bodyPr/><a:lstStyle/><a:p><a:pPr lvl="0"><a:lnSpc><a:spcPct val="125000"/></a:lnSpc><a:spcBef><a:spcPts val="0"/></a:spcBef><a:spcAft><a:spcPts val="0"/></a:spcAft><a:buNone/><a:defRPr sz="1300" b="1"><a:solidFill><a:srgbClr val="14213D"/></a:solidFill><a:latin typeface="Arial"/></a:defRPr></a:pPr><a:r><a:rPr lang="en-US" sz="1300" b="1"><a:solidFill><a:srgbClr val="14213D"/></a:solidFill><a:latin typeface="Arial"/></a:rPr><a:t>Responsibility</a:t></a:r></a:p></a:txBody><a:tcPr><a:lnB w="7200" cap="flat" cmpd="sng" algn="ctr"><a:solidFill><a:srgbClr val="DCDFE5"/></a:solidFill><a:prstDash val="solid"/><a:round/><a:headEnd type="none" w="med" len="med"/><a:tailEnd type="none" w="med" len="med"/></a:lnB><a:solidFill><a:srgbClr val="F7F6F2"/></a:solidFill></a:tcPr></a:tc><a:extLst><a:ext uri="{0D108BD9-81ED-4DB2-BD59-A6C34878D82A}"><a16:rowId xmlns:a16="http://schemas.microsoft.com/office/drawing/2014/main" val="2096825301"/></a:ext></a:extLst></a:tr><a:tr h="393699"><a:tc><a:txBody><a:bodyPr/><a:lstStyle/><a:p><a:pPr lvl="0"><a:lnSpc><a:spcPct val="125000"/></a:lnSpc><a:spcBef><a:spcPts val="0"/></a:spcBef><a:spcAft><a:spcPts val="0"/></a:spcAft><a:buNone/><a:defRPr sz="1300" b="0"><a:solidFill><a:srgbClr val="14213D"/></a:solidFill><a:latin typeface="Arial"/></a:defRPr></a:pPr><a:r><a:rPr lang="en-US" sz="1300" b="0"><a:solidFill><a:srgbClr val="14213D"/></a:solidFill><a:latin typeface="Arial"/></a:rPr><a:t>Harness</a:t></a:r></a:p></a:txBody><a:tcPr><a:lnT w="7200" cap="flat" cmpd="sng" algn="ctr"><a:solidFill><a:srgbClr val="DCDFE5"/></a:solidFill><a:prstDash val="solid"/><a:round/><a:headEnd type="none" w="med" len="med"/><a:tailEnd type="none" w="med" len="med"/></a:lnT><a:lnB w="7200" cap="flat" cmpd="sng" algn="ctr"><a:solidFill><a:srgbClr val="DCDFE5"/></a:solidFill><a:prstDash val="solid"/><a:round/><a:headEnd type="none" w="med" len="med"/><a:tailEnd type="none" w="med" len="med"/></a:lnB><a:solidFill><a:srgbClr val="F7F6F2"/></a:solidFill></a:tcPr></a:tc><a:tc><a:txBody><a:bodyPr/><a:lstStyle/><a:p><a:pPr lvl="0"><a:lnSpc><a:spcPct val="125000"/></a:lnSpc><a:spcBef><a:spcPts val="0"/></a:spcBef><a:spcAft><a:spcPts val="0"/></a:spcAft><a:buNone/><a:defRPr sz="1300" b="0"><a:solidFill><a:srgbClr val="14213D"/></a:solidFill><a:latin typeface="Arial"/></a:defRPr></a:pPr><a:r><a:rPr lang="en-US" sz="1300" b="0"><a:solidFill><a:srgbClr val="14213D"/></a:solidFill><a:latin typeface="Arial"/></a:rPr><a:t>Kerrian Gordon</a:t></a:r></a:p></a:txBody><a:tcPr><a:lnT w="7200" cap="flat" cmpd="sng" algn="ctr"><a:solidFill><a:srgbClr val="DCDFE5"/></a:solidFill><a:prstDash val="solid"/><a:round/><a:headEnd type="none" w="med" len="med"/><a:tailEnd type="none" w="med" len="med"/></a:lnT><a:lnB w="7200" cap="flat" cmpd="sng" algn="ctr"><a:solidFill><a:srgbClr val="DCDFE5"/></a:solidFill><a:prstDash val="solid"/><a:round/><a:headEnd type="none" w="med" len="med"/><a:tailEnd type="none" w="med" len="med"/></a:lnB><a:solidFill><a:srgbClr val="F7F6F2"/></a:solidFill></a:tcPr></a:tc><a:tc><a:txBody><a:bodyPr/><a:lstStyle/><a:p><a:pPr lvl="0"><a:lnSpc><a:spcPct val="125000"/></a:lnSpc><a:spcBef><a:spcPts val="0"/></a:spcBef><a:spcAft><a:spcPts val="0"/></a:spcAft><a:buNone/><a:defRPr sz="1300" b="0"><a:solidFill><a:srgbClr val="14213D"/></a:solidFill><a:latin typeface="Arial"/></a:defRPr></a:pPr><a:r><a:rPr lang="en-US" sz="1300" b="0"><a:solidFill><a:srgbClr val="14213D"/></a:solidFill><a:latin typeface="Arial"/></a:rPr><a:t>Run the review loop: check evidence, calculate, optional model copy, stop at a human report</a:t></a:r></a:p></a:txBody><a:tcPr><a:lnT w="7200" cap="flat" cmpd="sng" algn="ctr"><a:solidFill><a:srgbClr val="DCDFE5"/></a:solidFill><a:prstDash val="solid"/><a:round/><a:headEnd type="none" w="med" len="med"/><a:tailEnd type="none" w="med" len="med"/></a:lnT><a:lnB w="7200" cap="flat" cmpd="sng" algn="ctr"><a:solidFill><a:srgbClr val="DCDFE5"/></a:solidFill><a:prstDash val="solid"/><a:round/><a:headEnd type="none" w="med" len="med"/><a:tailEnd type="none" w="med" len="med"/></a:lnB><a:solidFill><a:srgbClr val="F7F6F2"/></a:solidFill></a:tcPr></a:tc><a:extLst><a:ext uri="{0D108BD9-81ED-4DB2-BD59-A6C34878D82A}"><a16:rowId xmlns:a16="http://schemas.microsoft.com/office/drawing/2014/main" val="2001623680"/></a:ext></a:extLst></a:tr><a:tr h="393699"><a:tc><a:txBody><a:bodyPr/><a:lstStyle/><a:p><a:pPr lvl="0"><a:lnSpc><a:spcPct val="125000"/></a:lnSpc><a:spcBef><a:spcPts val="0"/></a:spcBef><a:spcAft><a:spcPts val="0"/></a:spcAft><a:buNone/><a:defRPr sz="1300" b="0"><a:solidFill><a:srgbClr val="14213D"/></a:solidFill><a:latin typeface="Arial"/></a:defRPr></a:pPr><a:r><a:rPr lang="en-US" sz="1300" b="0"><a:solidFill><a:srgbClr val="14213D"/></a:solidFill><a:latin typeface="Arial"/></a:rPr><a:t>Tools + instructions</a:t></a:r></a:p></a:txBody><a:tcPr><a:lnT w="7200" cap="flat" cmpd="sng" algn="ctr"><a:solidFill><a:srgbClr val="DCDFE5"/></a:solidFill><a:prstDash val="solid"/><a:round/><a:headEnd type="none" w="med" len="med"/><a:tailEnd type="none" w="med" len="med"/></a:lnT><a:lnB w="7200" cap="flat" cmpd="sng" algn="ctr"><a:solidFill><a:srgbClr val="DCDFE5"/></a:solidFill><a:prstDash val="solid"/><a:round/><a:headEnd type="none" w="med" len="med"/><a:tailEnd type="none" w="med" len="med"/></a:lnB><a:solidFill><a:srgbClr val="F7F6F2"/></a:solidFill></a:tcPr></a:tc><a:tc><a:txBody><a:bodyPr/><a:lstStyle/><a:p><a:pPr lvl="0"><a:lnSpc><a:spcPct val="125000"/></a:lnSpc><a:spcBef><a:spcPts val="0"/></a:spcBef><a:spcAft><a:spcPts val="0"/></a:spcAft><a:buNone/><a:defRPr sz="1300" b="0"><a:solidFill><a:srgbClr val="14213D"/></a:solidFill><a:latin typeface="Arial"/></a:defRPr></a:pPr><a:r><a:rPr lang="en-US" sz="1300" b="0"><a:solidFill><a:srgbClr val="14213D"/></a:solidFill><a:latin typeface="Arial"/></a:rPr><a:t>Brahim Maouloud</a:t></a:r></a:p></a:txBody><a:tcPr><a:lnT w="7200" cap="flat" cmpd="sng" algn="ctr"><a:solidFill><a:srgbClr val="DCDFE5"/></a:solidFill><a:prstDash val="solid"/><a:round/><a:headEnd type="none" w="med" len="med"/><a:tailEnd type="none" w="med" len="med"/></a:lnT><a:lnB w="7200" cap="flat" cmpd="sng" algn="ctr"><a:solidFill><a:srgbClr val="DCDFE5"/></a:solidFill><a:prstDash val="solid"/><a:round/><a:headEnd type="none" w="med" len="med"/><a:tailEnd type="none" w="med" len="med"/></a:lnB><a:solidFill><a:srgbClr val="F7F6F2"/></a:solidFill></a:tcPr></a:tc><a:tc><a:txBody><a:bodyPr/><a:lstStyle/><a:p><a:pPr lvl="0"><a:lnSpc><a:spcPct val="125000"/></a:lnSpc><a:spcBef><a:spcPts val="0"/></a:spcBef><a:spcAft><a:spcPts val="0"/></a:spcAft><a:buNone/><a:defRPr sz="1300" b="0"><a:solidFill><a:srgbClr val="14213D"/></a:solidFill><a:latin typeface="Arial"/></a:defRPr></a:pPr><a:r><a:rPr lang="en-US" sz="1300" b="0"><a:solidFill><a:srgbClr val="14213D"/></a:solidFill><a:latin typeface="Arial"/></a:rPr><a:t>Inventory reader, FDA adapter, system prompt</a:t></a:r></a:p></a:txBody><a:tcPr><a:lnT w="7200" cap="flat" cmpd="sng" algn="ctr"><a:solidFill><a:srgbClr val="DCDFE5"/></a:solidFill><a:prstDash val="solid"/><a:round/><a:headEnd type="none" w="med" len="med"/><a:tailEnd type="none" w="med" len="med"/></a:lnT><a:lnB w="7200" cap="flat" cmpd="sng" algn="ctr"><a:solidFill><a:srgbClr val="DCDFE5"/></a:solidFill><a:prstDash val="solid"/><a:round/><a:headEnd type="none" w="med" len="med"/><a:tailEnd type="none" w="med" len="med"/></a:lnB><a:solidFill><a:srgbClr val="F7F6F2"/></a:solidFill></a:tcPr></a:tc><a:extLst><a:ext uri="{0D108BD9-81ED-4DB2-BD59-A6C34878D82A}"><a16:rowId xmlns:a16="http://schemas.microsoft.com/office/drawing/2014/main" val="2477041316"/></a:ext></a:extLst></a:tr><a:tr h="393699"><a:tc><a:txBody><a:bodyPr/><a:lstStyle/><a:p><a:pPr lvl="0"><a:lnSpc><a:spcPct val="125000"/></a:lnSpc><a:spcBef><a:spcPts val="0"/></a:spcBef><a:spcAft><a:spcPts val="0"/></a:spcAft><a:buNone/><a:defRPr sz="1300" b="0"><a:solidFill><a:srgbClr val="14213D"/></a:solidFill><a:latin typeface="Arial"/></a:defRPr></a:pPr><a:r><a:rPr lang="en-US" sz="1300" b="0"><a:solidFill><a:srgbClr val="14213D"/></a:solidFill><a:latin typeface="Arial"/></a:rPr><a:t>Prevention</a:t></a:r></a:p></a:txBody><a:tcPr><a:lnT w="7200" cap="flat" cmpd="sng" algn="ctr"><a:solidFill><a:srgbClr val="DCDFE5"/></a:solidFill><a:prstDash val="solid"/><a:round/><a:headEnd type="none" w="med" len="med"/><a:tailEnd type="none" w="med" len="med"/></a:lnT><a:lnB w="7200" cap="flat" cmpd="sng" algn="ctr"><a:solidFill><a:srgbClr val="DCDFE5"/></a:solidFill><a:prstDash val="solid"/><a:round/><a:headEnd type="none" w="med" len="med"/><a:tailEnd type="none" w="med" len="med"/></a:lnB><a:solidFill><a:srgbClr val="F7F6F2"/></a:solidFill></a:tcPr></a:tc><a:tc><a:txBody><a:bodyPr/><a:lstStyle/><a:p><a:pPr lvl="0"><a:lnSpc><a:spcPct val="125000"/></a:lnSpc><a:spcBef><a:spcPts val="0"/></a:spcBef><a:spcAft><a:spcPts val="0"/></a:spcAft><a:buNone/><a:defRPr sz="1300" b="0"><a:solidFill><a:srgbClr val="14213D"/></a:solidFill><a:latin typeface="Arial"/></a:defRPr></a:pPr><a:r><a:rPr lang="en-US" sz="1300" b="0"><a:solidFill><a:srgbClr val="14213D"/></a:solidFill><a:latin typeface="Arial"/></a:rPr><a:t>Emmanuel De Jesus</a:t></a:r></a:p></a:txBody><a:tcPr><a:lnT w="7200" cap="flat" cmpd="sng" algn="ctr"><a:solidFill><a:srgbClr val="DCDFE5"/></a:solidFill><a:prstDash val="solid"/><a:round/><a:headEnd type="none" w="med" len="med"/><a:tailEnd type="none" w="med" len="med"/></a:lnT><a:lnB w="7200" cap="flat" cmpd="sng" algn="ctr"><a:solidFill><a:srgbClr val="DCDFE5"/></a:solidFill><a:prstDash val="solid"/><a:round/><a:headEnd type="none" w="med" len="med"/><a:tailEnd type="none" w="med" len="med"/></a:lnB><a:solidFill><a:srgbClr val="F7F6F2"/></a:solidFill></a:tcPr></a:tc><a:tc><a:txBody><a:bodyPr/><a:lstStyle/><a:p><a:pPr lvl="0"><a:lnSpc><a:spcPct val="125000"/></a:lnSpc><a:spcBef><a:spcPts val="0"/></a:spcBef><a:spcAft><a:spcPts val="0"/></a:spcAft><a:buNone/><a:defRPr sz="1300" b="0"><a:solidFill><a:srgbClr val="14213D"/></a:solidFill><a:latin typeface="Arial"/></a:defRPr></a:pPr><a:r><a:rPr lang="en-US" sz="1300" b="0"><a:solidFill><a:srgbClr val="14213D"/></a:solidFill><a:latin typeface="Arial"/></a:rPr><a:t>Isolate context; enforce action and output contracts</a:t></a:r></a:p></a:txBody><a:tcPr><a:lnT w="7200" cap="flat" cmpd="sng" algn="ctr"><a:solidFill><a:srgbClr val="DCDFE5"/></a:solidFill><a:prstDash val="solid"/><a:round/><a:headEnd type="none" w="med" len="med"/><a:tailEnd type="none" w="med" len="med"/></a:lnT><a:lnB w="7200" cap="flat" cmpd="sng" algn="ctr"><a:solidFill><a:srgbClr val="DCDFE5"/></a:solidFill><a:prstDash val="solid"/><a:round/><a:headEnd type="none" w="med" len="med"/><a:tailEnd type="none" w="med" len="med"/></a:lnB><a:solidFill><a:srgbClr val="F7F6F2"/></a:solidFill></a:tcPr></a:tc><a:extLst><a:ext uri="{0D108BD9-81ED-4DB2-BD59-A6C34878D82A}"><a16:rowId xmlns:a16="http://schemas.microsoft.com/office/drawing/2014/main" val="2032191303"/></a:ext></a:extLst></a:tr></a:tbl></a:graphicData></a:graphic></p:graphicFrame><p:sp><p:nvSpPr><p:cNvPr id="9" name="Harness loop is live on synthetic data"><a:extLst><a:ext uri="{FF2B5EF4-FFF2-40B4-BE49-F238E27FC236}"><a16:creationId xmlns:a16="http://schemas.microsoft.com/office/drawing/2014/main" id="{1B42776B-B02E-645E-06CE-586C6DCFB2D2}"/></a:ext></a:extLst></p:cNvPr><p:cNvSpPr txBox="1"/><p:nvPr/></p:nvSpPr><p:spPr><a:xfrm><a:off x="812800" y="4737099"/><a:ext cx="10566399" cy="698500"/></a:xfrm><a:prstGeom prst="rect"><a:avLst/></a:prstGeom><a:noFill/><a:ln><a:noFill/></a:ln></p:spPr><p:txBody><a:bodyPr lIns="0" tIns="0" rIns="0" bIns="0" anchor="t"><a:noAutofit/></a:bodyPr><a:lstStyle/><a:p><a:pPr lvl="0"><a:lnSpc><a:spcPct val="140000"/></a:lnSpc><a:spcBef><a:spcPts val="0"/></a:spcBef><a:spcAft><a:spcPts val="0"/></a:spcAft><a:buNone/><a:defRPr sz="1400" b="0"><a:solidFill><a:srgbClr val="4A5568"/></a:solidFill><a:latin typeface="Arial"/></a:defRPr></a:pPr><a:r><a:rPr lang="en-US" sz="1400" b="0"><a:solidFill><a:srgbClr val="4A5568"/></a:solidFill><a:latin typeface="Arial"/></a:rPr><a:t>Harness loop is live on synthetic data: it starts on a review run, checkpoints at each guard, and stops when the human report is ready (or the model answer is rejected / unavailable).</a:t></a:r></a:p></p:txBody></p:sp></p:spTree></p:cSld><p:clrMapOvr><a:masterClrMapping/></p:clrMapOvr></p:sld>
+<file path=ppt/slides/slide3.xml><?xml version="1.0" encoding="utf-8"?>
+<p:sld xmlns:a="http://schemas.openxmlformats.org/drawingml/2006/main" xmlns:r="http://schemas.openxmlformats.org/officeDocument/2006/relationships" xmlns:p="http://schemas.openxmlformats.org/presentationml/2006/main">
+  <p:cSld name="arch">
+    <p:spTree>
+      <p:nvGrpSpPr>
+        <p:cNvPr id="1" name=""/>
+        <p:cNvGrpSpPr/>
+        <p:nvPr/>
+      </p:nvGrpSpPr>
+      <p:grpSpPr>
+        <a:xfrm>
+          <a:off x="0" y="0"/>
+          <a:ext cx="0" cy="0"/>
+          <a:chOff x="0" y="0"/>
+          <a:chExt cx="0" cy="0"/>
+        </a:xfrm>
+      </p:grpSpPr>
+      <p:sp>
+        <p:nvSpPr>
+          <p:cNvPr id="2" name="Background">
+            <a:extLst>
+              <a:ext uri="{FF2B5EF4-FFF2-40B4-BE49-F238E27FC236}">
+                <a16:creationId xmlns:a16="http://schemas.microsoft.com/office/drawing/2014/main" id="{C14C7F5C-0DB5-ABDD-3895-8EF4D0615D0C}"/>
+              </a:ext>
+            </a:extLst>
+          </p:cNvPr>
+          <p:cNvSpPr txBox="1"/>
+          <p:nvPr/>
+        </p:nvSpPr>
+        <p:spPr>
+          <a:xfrm>
+            <a:off x="0" y="0"/>
+            <a:ext cx="12192001" cy="6858000"/>
+          </a:xfrm>
+          <a:prstGeom prst="rect">
+            <a:avLst/>
+          </a:prstGeom>
+          <a:solidFill>
+            <a:srgbClr val="F7F6F2"/>
+          </a:solidFill>
+          <a:ln>
+            <a:noFill/>
+          </a:ln>
+        </p:spPr>
+        <p:txBody>
+          <a:bodyPr lIns="0" tIns="0" rIns="0" bIns="0"/>
+          <a:lstStyle/>
+          <a:p>
+            <a:endParaRPr lang="en-US"/>
+          </a:p>
+        </p:txBody>
+      </p:sp>
+      <p:sp>
+        <p:nvSpPr>
+          <p:cNvPr id="3" name="ARCHITECTURE">
+            <a:extLst>
+              <a:ext uri="{FF2B5EF4-FFF2-40B4-BE49-F238E27FC236}">
+                <a16:creationId xmlns:a16="http://schemas.microsoft.com/office/drawing/2014/main" id="{6E8CED4E-396E-238B-3B51-F99A757A206D}"/>
+              </a:ext>
+            </a:extLst>
+          </p:cNvPr>
+          <p:cNvSpPr txBox="1"/>
+          <p:nvPr/>
+        </p:nvSpPr>
+        <p:spPr>
+          <a:xfrm>
+            <a:off x="812800" y="812800"/>
+            <a:ext cx="10566399" cy="254001"/>
+          </a:xfrm>
+          <a:prstGeom prst="rect">
+            <a:avLst/>
+          </a:prstGeom>
+          <a:noFill/>
+          <a:ln>
+            <a:noFill/>
+          </a:ln>
+        </p:spPr>
+        <p:txBody>
+          <a:bodyPr lIns="0" tIns="0" rIns="0" bIns="0" anchor="t">
+            <a:noAutofit/>
+          </a:bodyPr>
+          <a:lstStyle/>
+          <a:p>
+            <a:pPr lvl="0">
+              <a:lnSpc>
+                <a:spcPct val="120000"/>
+              </a:lnSpc>
+              <a:spcBef>
+                <a:spcPts val="0"/>
+              </a:spcBef>
+              <a:spcAft>
+                <a:spcPts val="0"/>
+              </a:spcAft>
+              <a:buNone/>
+              <a:defRPr sz="1200" b="0">
+                <a:solidFill>
+                  <a:srgbClr val="B44E14"/>
+                </a:solidFill>
+                <a:latin typeface="Courier New"/>
+              </a:defRPr>
+            </a:pPr>
+            <a:r>
+              <a:rPr lang="en-US" sz="1200" b="0">
+                <a:solidFill>
+                  <a:srgbClr val="B44E14"/>
+                </a:solidFill>
+                <a:latin typeface="Courier New"/>
+              </a:rPr>
+              <a:t>ARCHITECTURE</a:t>
+            </a:r>
+          </a:p>
+        </p:txBody>
+      </p:sp>
+      <p:sp>
+        <p:nvSpPr>
+          <p:cNvPr id="4" name="Three parts, every step guarded">
+            <a:extLst>
+              <a:ext uri="{FF2B5EF4-FFF2-40B4-BE49-F238E27FC236}">
+                <a16:creationId xmlns:a16="http://schemas.microsoft.com/office/drawing/2014/main" id="{B90BEA9F-C1F6-2274-423E-D913BCAD32CA}"/>
+              </a:ext>
+            </a:extLst>
+          </p:cNvPr>
+          <p:cNvSpPr txBox="1"/>
+          <p:nvPr/>
+        </p:nvSpPr>
+        <p:spPr>
+          <a:xfrm>
+            <a:off x="812800" y="1143000"/>
+            <a:ext cx="10566399" cy="984250"/>
+          </a:xfrm>
+          <a:prstGeom prst="rect">
+            <a:avLst/>
+          </a:prstGeom>
+          <a:noFill/>
+          <a:ln>
+            <a:noFill/>
+          </a:ln>
+        </p:spPr>
+        <p:txBody>
+          <a:bodyPr lIns="0" tIns="0" rIns="0" bIns="0" anchor="t">
+            <a:noAutofit/>
+          </a:bodyPr>
+          <a:lstStyle/>
+          <a:p>
+            <a:pPr lvl="0">
+              <a:lnSpc>
+                <a:spcPct val="110000"/>
+              </a:lnSpc>
+              <a:spcBef>
+                <a:spcPts val="0"/>
+              </a:spcBef>
+              <a:spcAft>
+                <a:spcPts val="0"/>
+              </a:spcAft>
+              <a:buNone/>
+              <a:defRPr sz="3200" b="1">
+                <a:solidFill>
+                  <a:srgbClr val="14213D"/>
+                </a:solidFill>
+                <a:latin typeface="Arial"/>
+              </a:defRPr>
+            </a:pPr>
+            <a:r>
+              <a:rPr lang="en-US" sz="3200" b="1">
+                <a:solidFill>
+                  <a:srgbClr val="14213D"/>
+                </a:solidFill>
+                <a:latin typeface="Arial"/>
+              </a:rPr>
+              <a:t>Three parts, every step guarded</a:t>
+            </a:r>
+          </a:p>
+        </p:txBody>
+      </p:sp>
+      <p:sp>
+        <p:nvSpPr>
+          <p:cNvPr id="5" name="Pharmacy-AGENT · Synthetic tests; human operationa">
+            <a:extLst>
+              <a:ext uri="{FF2B5EF4-FFF2-40B4-BE49-F238E27FC236}">
+                <a16:creationId xmlns:a16="http://schemas.microsoft.com/office/drawing/2014/main" id="{B44CA3A5-DF7C-B4B1-CF35-B39B47E231FF}"/>
+              </a:ext>
+            </a:extLst>
+          </p:cNvPr>
+          <p:cNvSpPr txBox="1"/>
+          <p:nvPr/>
+        </p:nvSpPr>
+        <p:spPr>
+          <a:xfrm>
+            <a:off x="812800" y="6222999"/>
+            <a:ext cx="10566399" cy="279399"/>
+          </a:xfrm>
+          <a:prstGeom prst="rect">
+            <a:avLst/>
+          </a:prstGeom>
+          <a:noFill/>
+          <a:ln>
+            <a:noFill/>
+          </a:ln>
+        </p:spPr>
+        <p:txBody>
+          <a:bodyPr lIns="0" tIns="0" rIns="0" bIns="0" anchor="t">
+            <a:noAutofit/>
+          </a:bodyPr>
+          <a:lstStyle/>
+          <a:p>
+            <a:pPr lvl="0">
+              <a:lnSpc>
+                <a:spcPct val="120000"/>
+              </a:lnSpc>
+              <a:spcBef>
+                <a:spcPts val="0"/>
+              </a:spcBef>
+              <a:spcAft>
+                <a:spcPts val="0"/>
+              </a:spcAft>
+              <a:buNone/>
+              <a:defRPr sz="1200" b="0">
+                <a:solidFill>
+                  <a:srgbClr val="6A7385"/>
+                </a:solidFill>
+                <a:latin typeface="Arial"/>
+              </a:defRPr>
+            </a:pPr>
+            <a:r>
+              <a:rPr lang="en-US" sz="1200" b="0">
+                <a:solidFill>
+                  <a:srgbClr val="6A7385"/>
+                </a:solidFill>
+                <a:latin typeface="Arial"/>
+              </a:rPr>
+              <a:t>Pharmacy-AGENT · Synthetic tests; human operational decisions · 3 / 10</a:t>
+            </a:r>
+          </a:p>
+        </p:txBody>
+      </p:sp>
+      <p:sp>
+        <p:nvSpPr>
+          <p:cNvPr id="6" name="Background">
+            <a:extLst>
+              <a:ext uri="{FF2B5EF4-FFF2-40B4-BE49-F238E27FC236}">
+                <a16:creationId xmlns:a16="http://schemas.microsoft.com/office/drawing/2014/main" id="{78CB14F0-6999-E156-9039-E345A07641E6}"/>
+              </a:ext>
+            </a:extLst>
+          </p:cNvPr>
+          <p:cNvSpPr txBox="1"/>
+          <p:nvPr/>
+        </p:nvSpPr>
+        <p:spPr>
+          <a:xfrm>
+            <a:off x="812800" y="1854201"/>
+            <a:ext cx="10566399" cy="571500"/>
+          </a:xfrm>
+          <a:prstGeom prst="rect">
+            <a:avLst/>
+          </a:prstGeom>
+          <a:solidFill>
+            <a:srgbClr val="E8EBF1"/>
+          </a:solidFill>
+          <a:ln>
+            <a:noFill/>
+          </a:ln>
+        </p:spPr>
+        <p:txBody>
+          <a:bodyPr lIns="0" tIns="0" rIns="0" bIns="0"/>
+          <a:lstStyle/>
+          <a:p>
+            <a:endParaRPr lang="en-US"/>
+          </a:p>
+        </p:txBody>
+      </p:sp>
+      <p:sp>
+        <p:nvSpPr>
+          <p:cNvPr id="7" name="Input → validation → minimal facts → model → guard">
+            <a:extLst>
+              <a:ext uri="{FF2B5EF4-FFF2-40B4-BE49-F238E27FC236}">
+                <a16:creationId xmlns:a16="http://schemas.microsoft.com/office/drawing/2014/main" id="{C0AB4FCF-4861-AD57-1148-6196C4DD1EBE}"/>
+              </a:ext>
+            </a:extLst>
+          </p:cNvPr>
+          <p:cNvSpPr txBox="1"/>
+          <p:nvPr/>
+        </p:nvSpPr>
+        <p:spPr>
+          <a:xfrm>
+            <a:off x="990601" y="2006600"/>
+            <a:ext cx="10210798" cy="380998"/>
+          </a:xfrm>
+          <a:prstGeom prst="rect">
+            <a:avLst/>
+          </a:prstGeom>
+          <a:noFill/>
+          <a:ln>
+            <a:noFill/>
+          </a:ln>
+        </p:spPr>
+        <p:txBody>
+          <a:bodyPr lIns="0" tIns="0" rIns="0" bIns="0" anchor="t">
+            <a:noAutofit/>
+          </a:bodyPr>
+          <a:lstStyle/>
+          <a:p>
+            <a:pPr lvl="0">
+              <a:lnSpc>
+                <a:spcPct val="120000"/>
+              </a:lnSpc>
+              <a:spcBef>
+                <a:spcPts val="0"/>
+              </a:spcBef>
+              <a:spcAft>
+                <a:spcPts val="0"/>
+              </a:spcAft>
+              <a:buNone/>
+              <a:defRPr sz="1300" b="0">
+                <a:solidFill>
+                  <a:srgbClr val="14213D"/>
+                </a:solidFill>
+                <a:latin typeface="Courier New"/>
+              </a:defRPr>
+            </a:pPr>
+            <a:r>
+              <a:rPr lang="en-US" sz="1300" b="0">
+                <a:solidFill>
+                  <a:srgbClr val="14213D"/>
+                </a:solidFill>
+                <a:latin typeface="Courier New"/>
+              </a:rPr>
+              <a:t>Input → guarded reads → calculate &amp; assemble → one model copy → validate → human</a:t>
+            </a:r>
+          </a:p>
+        </p:txBody>
+      </p:sp>
+      <p:graphicFrame>
+        <p:nvGraphicFramePr>
+          <p:cNvPr id="8" name="Table 7">
+            <a:extLst>
+              <a:ext uri="{FF2B5EF4-FFF2-40B4-BE49-F238E27FC236}">
+                <a16:creationId xmlns:a16="http://schemas.microsoft.com/office/drawing/2014/main" id="{8A47B976-AB0B-6087-E5C3-591297443A8E}"/>
+              </a:ext>
+            </a:extLst>
+          </p:cNvPr>
+          <p:cNvGraphicFramePr>
+            <a:graphicFrameLocks noGrp="1"/>
+          </p:cNvGraphicFramePr>
+          <p:nvPr/>
+        </p:nvGraphicFramePr>
+        <p:xfrm>
+          <a:off x="812800" y="2730499"/>
+          <a:ext cx="10566399" cy="1574798"/>
+        </p:xfrm>
+        <a:graphic>
+          <a:graphicData uri="http://schemas.openxmlformats.org/drawingml/2006/table">
+            <a:tbl>
+              <a:tblPr/>
+              <a:tblGrid>
+                <a:gridCol w="2535937">
+                  <a:extLst>
+                    <a:ext uri="{9D8B030D-6E8A-4147-A177-3AD203B41FA5}">
+                      <a16:colId xmlns:a16="http://schemas.microsoft.com/office/drawing/2014/main" val="1096448313"/>
+                    </a:ext>
+                  </a:extLst>
+                </a:gridCol>
+                <a:gridCol w="2535937">
+                  <a:extLst>
+                    <a:ext uri="{9D8B030D-6E8A-4147-A177-3AD203B41FA5}">
+                      <a16:colId xmlns:a16="http://schemas.microsoft.com/office/drawing/2014/main" val="1922132533"/>
+                    </a:ext>
+                  </a:extLst>
+                </a:gridCol>
+                <a:gridCol w="5494528">
+                  <a:extLst>
+                    <a:ext uri="{9D8B030D-6E8A-4147-A177-3AD203B41FA5}">
+                      <a16:colId xmlns:a16="http://schemas.microsoft.com/office/drawing/2014/main" val="3085363466"/>
+                    </a:ext>
+                  </a:extLst>
+                </a:gridCol>
+              </a:tblGrid>
+              <a:tr h="393699">
+                <a:tc>
+                  <a:txBody>
+                    <a:bodyPr/>
+                    <a:lstStyle/>
+                    <a:p>
+                      <a:pPr lvl="0">
+                        <a:lnSpc>
+                          <a:spcPct val="125000"/>
+                        </a:lnSpc>
+                        <a:spcBef>
+                          <a:spcPts val="0"/>
+                        </a:spcBef>
+                        <a:spcAft>
+                          <a:spcPts val="0"/>
+                        </a:spcAft>
+                        <a:buNone/>
+                        <a:defRPr sz="1300" b="1">
+                          <a:solidFill>
+                            <a:srgbClr val="14213D"/>
+                          </a:solidFill>
+                          <a:latin typeface="Arial"/>
+                        </a:defRPr>
+                      </a:pPr>
+                      <a:r>
+                        <a:rPr lang="en-US" sz="1300" b="1">
+                          <a:solidFill>
+                            <a:srgbClr val="14213D"/>
+                          </a:solidFill>
+                          <a:latin typeface="Arial"/>
+                        </a:rPr>
+                        <a:t>Component</a:t>
+                      </a:r>
+                    </a:p>
+                  </a:txBody>
+                  <a:tcPr>
+                    <a:lnB w="7200" cap="flat" cmpd="sng" algn="ctr">
+                      <a:solidFill>
+                        <a:srgbClr val="DCDFE5"/>
+                      </a:solidFill>
+                      <a:prstDash val="solid"/>
+                      <a:round/>
+                      <a:headEnd type="none" w="med" len="med"/>
+                      <a:tailEnd type="none" w="med" len="med"/>
+                    </a:lnB>
+                    <a:solidFill>
+                      <a:srgbClr val="F7F6F2"/>
+                    </a:solidFill>
+                  </a:tcPr>
+                </a:tc>
+                <a:tc>
+                  <a:txBody>
+                    <a:bodyPr/>
+                    <a:lstStyle/>
+                    <a:p>
+                      <a:pPr lvl="0">
+                        <a:lnSpc>
+                          <a:spcPct val="125000"/>
+                        </a:lnSpc>
+                        <a:spcBef>
+                          <a:spcPts val="0"/>
+                        </a:spcBef>
+                        <a:spcAft>
+                          <a:spcPts val="0"/>
+                        </a:spcAft>
+                        <a:buNone/>
+                        <a:defRPr sz="1300" b="1">
+                          <a:solidFill>
+                            <a:srgbClr val="14213D"/>
+                          </a:solidFill>
+                          <a:latin typeface="Arial"/>
+                        </a:defRPr>
+                      </a:pPr>
+                      <a:r>
+                        <a:rPr lang="en-US" sz="1300" b="1">
+                          <a:solidFill>
+                            <a:srgbClr val="14213D"/>
+                          </a:solidFill>
+                          <a:latin typeface="Arial"/>
+                        </a:rPr>
+                        <a:t>Owner</a:t>
+                      </a:r>
+                    </a:p>
+                  </a:txBody>
+                  <a:tcPr>
+                    <a:lnB w="7200" cap="flat" cmpd="sng" algn="ctr">
+                      <a:solidFill>
+                        <a:srgbClr val="DCDFE5"/>
+                      </a:solidFill>
+                      <a:prstDash val="solid"/>
+                      <a:round/>
+                      <a:headEnd type="none" w="med" len="med"/>
+                      <a:tailEnd type="none" w="med" len="med"/>
+                    </a:lnB>
+                    <a:solidFill>
+                      <a:srgbClr val="F7F6F2"/>
+                    </a:solidFill>
+                  </a:tcPr>
+                </a:tc>
+                <a:tc>
+                  <a:txBody>
+                    <a:bodyPr/>
+                    <a:lstStyle/>
+                    <a:p>
+                      <a:pPr lvl="0">
+                        <a:lnSpc>
+                          <a:spcPct val="125000"/>
+                        </a:lnSpc>
+                        <a:spcBef>
+                          <a:spcPts val="0"/>
+                        </a:spcBef>
+                        <a:spcAft>
+                          <a:spcPts val="0"/>
+                        </a:spcAft>
+                        <a:buNone/>
+                        <a:defRPr sz="1300" b="1">
+                          <a:solidFill>
+                            <a:srgbClr val="14213D"/>
+                          </a:solidFill>
+                          <a:latin typeface="Arial"/>
+                        </a:defRPr>
+                      </a:pPr>
+                      <a:r>
+                        <a:rPr lang="en-US" sz="1300" b="1">
+                          <a:solidFill>
+                            <a:srgbClr val="14213D"/>
+                          </a:solidFill>
+                          <a:latin typeface="Arial"/>
+                        </a:rPr>
+                        <a:t>Responsibility</a:t>
+                      </a:r>
+                    </a:p>
+                  </a:txBody>
+                  <a:tcPr>
+                    <a:lnB w="7200" cap="flat" cmpd="sng" algn="ctr">
+                      <a:solidFill>
+                        <a:srgbClr val="DCDFE5"/>
+                      </a:solidFill>
+                      <a:prstDash val="solid"/>
+                      <a:round/>
+                      <a:headEnd type="none" w="med" len="med"/>
+                      <a:tailEnd type="none" w="med" len="med"/>
+                    </a:lnB>
+                    <a:solidFill>
+                      <a:srgbClr val="F7F6F2"/>
+                    </a:solidFill>
+                  </a:tcPr>
+                </a:tc>
+                <a:extLst>
+                  <a:ext uri="{0D108BD9-81ED-4DB2-BD59-A6C34878D82A}">
+                    <a16:rowId xmlns:a16="http://schemas.microsoft.com/office/drawing/2014/main" val="2096825301"/>
+                  </a:ext>
+                </a:extLst>
+              </a:tr>
+              <a:tr h="393699">
+                <a:tc>
+                  <a:txBody>
+                    <a:bodyPr/>
+                    <a:lstStyle/>
+                    <a:p>
+                      <a:pPr lvl="0">
+                        <a:lnSpc>
+                          <a:spcPct val="125000"/>
+                        </a:lnSpc>
+                        <a:spcBef>
+                          <a:spcPts val="0"/>
+                        </a:spcBef>
+                        <a:spcAft>
+                          <a:spcPts val="0"/>
+                        </a:spcAft>
+                        <a:buNone/>
+                        <a:defRPr sz="1300" b="0">
+                          <a:solidFill>
+                            <a:srgbClr val="14213D"/>
+                          </a:solidFill>
+                          <a:latin typeface="Arial"/>
+                        </a:defRPr>
+                      </a:pPr>
+                      <a:r>
+                        <a:rPr lang="en-US" sz="1300" b="0">
+                          <a:solidFill>
+                            <a:srgbClr val="14213D"/>
+                          </a:solidFill>
+                          <a:latin typeface="Arial"/>
+                        </a:rPr>
+                        <a:t>Harness</a:t>
+                      </a:r>
+                    </a:p>
+                  </a:txBody>
+                  <a:tcPr>
+                    <a:lnT w="7200" cap="flat" cmpd="sng" algn="ctr">
+                      <a:solidFill>
+                        <a:srgbClr val="DCDFE5"/>
+                      </a:solidFill>
+                      <a:prstDash val="solid"/>
+                      <a:round/>
+                      <a:headEnd type="none" w="med" len="med"/>
+                      <a:tailEnd type="none" w="med" len="med"/>
+                    </a:lnT>
+                    <a:lnB w="7200" cap="flat" cmpd="sng" algn="ctr">
+                      <a:solidFill>
+                        <a:srgbClr val="DCDFE5"/>
+                      </a:solidFill>
+                      <a:prstDash val="solid"/>
+                      <a:round/>
+                      <a:headEnd type="none" w="med" len="med"/>
+                      <a:tailEnd type="none" w="med" len="med"/>
+                    </a:lnB>
+                    <a:solidFill>
+                      <a:srgbClr val="F7F6F2"/>
+                    </a:solidFill>
+                  </a:tcPr>
+                </a:tc>
+                <a:tc>
+                  <a:txBody>
+                    <a:bodyPr/>
+                    <a:lstStyle/>
+                    <a:p>
+                      <a:pPr lvl="0">
+                        <a:lnSpc>
+                          <a:spcPct val="125000"/>
+                        </a:lnSpc>
+                        <a:spcBef>
+                          <a:spcPts val="0"/>
+                        </a:spcBef>
+                        <a:spcAft>
+                          <a:spcPts val="0"/>
+                        </a:spcAft>
+                        <a:buNone/>
+                        <a:defRPr sz="1300" b="0">
+                          <a:solidFill>
+                            <a:srgbClr val="14213D"/>
+                          </a:solidFill>
+                          <a:latin typeface="Arial"/>
+                        </a:defRPr>
+                      </a:pPr>
+                      <a:r>
+                        <a:rPr lang="en-US" sz="1300" b="0">
+                          <a:solidFill>
+                            <a:srgbClr val="14213D"/>
+                          </a:solidFill>
+                          <a:latin typeface="Arial"/>
+                        </a:rPr>
+                        <a:t>Kerrian Gordon</a:t>
+                      </a:r>
+                    </a:p>
+                  </a:txBody>
+                  <a:tcPr>
+                    <a:lnT w="7200" cap="flat" cmpd="sng" algn="ctr">
+                      <a:solidFill>
+                        <a:srgbClr val="DCDFE5"/>
+                      </a:solidFill>
+                      <a:prstDash val="solid"/>
+                      <a:round/>
+                      <a:headEnd type="none" w="med" len="med"/>
+                      <a:tailEnd type="none" w="med" len="med"/>
+                    </a:lnT>
+                    <a:lnB w="7200" cap="flat" cmpd="sng" algn="ctr">
+                      <a:solidFill>
+                        <a:srgbClr val="DCDFE5"/>
+                      </a:solidFill>
+                      <a:prstDash val="solid"/>
+                      <a:round/>
+                      <a:headEnd type="none" w="med" len="med"/>
+                      <a:tailEnd type="none" w="med" len="med"/>
+                    </a:lnB>
+                    <a:solidFill>
+                      <a:srgbClr val="F7F6F2"/>
+                    </a:solidFill>
+                  </a:tcPr>
+                </a:tc>
+                <a:tc>
+                  <a:txBody>
+                    <a:bodyPr/>
+                    <a:lstStyle/>
+                    <a:p>
+                      <a:pPr lvl="0">
+                        <a:lnSpc>
+                          <a:spcPct val="125000"/>
+                        </a:lnSpc>
+                        <a:spcBef>
+                          <a:spcPts val="0"/>
+                        </a:spcBef>
+                        <a:spcAft>
+                          <a:spcPts val="0"/>
+                        </a:spcAft>
+                        <a:buNone/>
+                        <a:defRPr sz="1300" b="0">
+                          <a:solidFill>
+                            <a:srgbClr val="14213D"/>
+                          </a:solidFill>
+                          <a:latin typeface="Arial"/>
+                        </a:defRPr>
+                      </a:pPr>
+                      <a:r>
+                        <a:rPr lang="en-US" sz="1300" b="0">
+                          <a:solidFill>
+                            <a:srgbClr val="14213D"/>
+                          </a:solidFill>
+                          <a:latin typeface="Arial"/>
+                        </a:rPr>
+                        <a:t>Run the review loop: check evidence, calculate, optional model copy, stop at a human report</a:t>
+                      </a:r>
+                    </a:p>
+                  </a:txBody>
+                  <a:tcPr>
+                    <a:lnT w="7200" cap="flat" cmpd="sng" algn="ctr">
+                      <a:solidFill>
+                        <a:srgbClr val="DCDFE5"/>
+                      </a:solidFill>
+                      <a:prstDash val="solid"/>
+                      <a:round/>
+                      <a:headEnd type="none" w="med" len="med"/>
+                      <a:tailEnd type="none" w="med" len="med"/>
+                    </a:lnT>
+                    <a:lnB w="7200" cap="flat" cmpd="sng" algn="ctr">
+                      <a:solidFill>
+                        <a:srgbClr val="DCDFE5"/>
+                      </a:solidFill>
+                      <a:prstDash val="solid"/>
+                      <a:round/>
+                      <a:headEnd type="none" w="med" len="med"/>
+                      <a:tailEnd type="none" w="med" len="med"/>
+                    </a:lnB>
+                    <a:solidFill>
+                      <a:srgbClr val="F7F6F2"/>
+                    </a:solidFill>
+                  </a:tcPr>
+                </a:tc>
+                <a:extLst>
+                  <a:ext uri="{0D108BD9-81ED-4DB2-BD59-A6C34878D82A}">
+                    <a16:rowId xmlns:a16="http://schemas.microsoft.com/office/drawing/2014/main" val="2001623680"/>
+                  </a:ext>
+                </a:extLst>
+              </a:tr>
+              <a:tr h="393699">
+                <a:tc>
+                  <a:txBody>
+                    <a:bodyPr/>
+                    <a:lstStyle/>
+                    <a:p>
+                      <a:pPr lvl="0">
+                        <a:lnSpc>
+                          <a:spcPct val="125000"/>
+                        </a:lnSpc>
+                        <a:spcBef>
+                          <a:spcPts val="0"/>
+                        </a:spcBef>
+                        <a:spcAft>
+                          <a:spcPts val="0"/>
+                        </a:spcAft>
+                        <a:buNone/>
+                        <a:defRPr sz="1300" b="0">
+                          <a:solidFill>
+                            <a:srgbClr val="14213D"/>
+                          </a:solidFill>
+                          <a:latin typeface="Arial"/>
+                        </a:defRPr>
+                      </a:pPr>
+                      <a:r>
+                        <a:rPr lang="en-US" sz="1300" b="0">
+                          <a:solidFill>
+                            <a:srgbClr val="14213D"/>
+                          </a:solidFill>
+                          <a:latin typeface="Arial"/>
+                        </a:rPr>
+                        <a:t>Tools + instructions</a:t>
+                      </a:r>
+                    </a:p>
+                  </a:txBody>
+                  <a:tcPr>
+                    <a:lnT w="7200" cap="flat" cmpd="sng" algn="ctr">
+                      <a:solidFill>
+                        <a:srgbClr val="DCDFE5"/>
+                      </a:solidFill>
+                      <a:prstDash val="solid"/>
+                      <a:round/>
+                      <a:headEnd type="none" w="med" len="med"/>
+                      <a:tailEnd type="none" w="med" len="med"/>
+                    </a:lnT>
+                    <a:lnB w="7200" cap="flat" cmpd="sng" algn="ctr">
+                      <a:solidFill>
+                        <a:srgbClr val="DCDFE5"/>
+                      </a:solidFill>
+                      <a:prstDash val="solid"/>
+                      <a:round/>
+                      <a:headEnd type="none" w="med" len="med"/>
+                      <a:tailEnd type="none" w="med" len="med"/>
+                    </a:lnB>
+                    <a:solidFill>
+                      <a:srgbClr val="F7F6F2"/>
+                    </a:solidFill>
+                  </a:tcPr>
+                </a:tc>
+                <a:tc>
+                  <a:txBody>
+                    <a:bodyPr/>
+                    <a:lstStyle/>
+                    <a:p>
+                      <a:pPr lvl="0">
+                        <a:lnSpc>
+                          <a:spcPct val="125000"/>
+                        </a:lnSpc>
+                        <a:spcBef>
+                          <a:spcPts val="0"/>
+                        </a:spcBef>
+                        <a:spcAft>
+                          <a:spcPts val="0"/>
+                        </a:spcAft>
+                        <a:buNone/>
+                        <a:defRPr sz="1300" b="0">
+                          <a:solidFill>
+                            <a:srgbClr val="14213D"/>
+                          </a:solidFill>
+                          <a:latin typeface="Arial"/>
+                        </a:defRPr>
+                      </a:pPr>
+                      <a:r>
+                        <a:rPr lang="en-US" sz="1300" b="0">
+                          <a:solidFill>
+                            <a:srgbClr val="14213D"/>
+                          </a:solidFill>
+                          <a:latin typeface="Arial"/>
+                        </a:rPr>
+                        <a:t>Brahim Maouloud</a:t>
+                      </a:r>
+                    </a:p>
+                  </a:txBody>
+                  <a:tcPr>
+                    <a:lnT w="7200" cap="flat" cmpd="sng" algn="ctr">
+                      <a:solidFill>
+                        <a:srgbClr val="DCDFE5"/>
+                      </a:solidFill>
+                      <a:prstDash val="solid"/>
+                      <a:round/>
+                      <a:headEnd type="none" w="med" len="med"/>
+                      <a:tailEnd type="none" w="med" len="med"/>
+                    </a:lnT>
+                    <a:lnB w="7200" cap="flat" cmpd="sng" algn="ctr">
+                      <a:solidFill>
+                        <a:srgbClr val="DCDFE5"/>
+                      </a:solidFill>
+                      <a:prstDash val="solid"/>
+                      <a:round/>
+                      <a:headEnd type="none" w="med" len="med"/>
+                      <a:tailEnd type="none" w="med" len="med"/>
+                    </a:lnB>
+                    <a:solidFill>
+                      <a:srgbClr val="F7F6F2"/>
+                    </a:solidFill>
+                  </a:tcPr>
+                </a:tc>
+                <a:tc>
+                  <a:txBody>
+                    <a:bodyPr/>
+                    <a:lstStyle/>
+                    <a:p>
+                      <a:pPr lvl="0">
+                        <a:lnSpc>
+                          <a:spcPct val="125000"/>
+                        </a:lnSpc>
+                        <a:spcBef>
+                          <a:spcPts val="0"/>
+                        </a:spcBef>
+                        <a:spcAft>
+                          <a:spcPts val="0"/>
+                        </a:spcAft>
+                        <a:buNone/>
+                        <a:defRPr sz="1300" b="0">
+                          <a:solidFill>
+                            <a:srgbClr val="14213D"/>
+                          </a:solidFill>
+                          <a:latin typeface="Arial"/>
+                        </a:defRPr>
+                      </a:pPr>
+                      <a:r>
+                        <a:rPr lang="en-US" sz="1300" b="0">
+                          <a:solidFill>
+                            <a:srgbClr val="14213D"/>
+                          </a:solidFill>
+                          <a:latin typeface="Arial"/>
+                        </a:rPr>
+                        <a:t>Inventory reader, FDA adapter, system prompt</a:t>
+                      </a:r>
+                    </a:p>
+                  </a:txBody>
+                  <a:tcPr>
+                    <a:lnT w="7200" cap="flat" cmpd="sng" algn="ctr">
+                      <a:solidFill>
+                        <a:srgbClr val="DCDFE5"/>
+                      </a:solidFill>
+                      <a:prstDash val="solid"/>
+                      <a:round/>
+                      <a:headEnd type="none" w="med" len="med"/>
+                      <a:tailEnd type="none" w="med" len="med"/>
+                    </a:lnT>
+                    <a:lnB w="7200" cap="flat" cmpd="sng" algn="ctr">
+                      <a:solidFill>
+                        <a:srgbClr val="DCDFE5"/>
+                      </a:solidFill>
+                      <a:prstDash val="solid"/>
+                      <a:round/>
+                      <a:headEnd type="none" w="med" len="med"/>
+                      <a:tailEnd type="none" w="med" len="med"/>
+                    </a:lnB>
+                    <a:solidFill>
+                      <a:srgbClr val="F7F6F2"/>
+                    </a:solidFill>
+                  </a:tcPr>
+                </a:tc>
+                <a:extLst>
+                  <a:ext uri="{0D108BD9-81ED-4DB2-BD59-A6C34878D82A}">
+                    <a16:rowId xmlns:a16="http://schemas.microsoft.com/office/drawing/2014/main" val="2477041316"/>
+                  </a:ext>
+                </a:extLst>
+              </a:tr>
+              <a:tr h="393699">
+                <a:tc>
+                  <a:txBody>
+                    <a:bodyPr/>
+                    <a:lstStyle/>
+                    <a:p>
+                      <a:pPr lvl="0">
+                        <a:lnSpc>
+                          <a:spcPct val="125000"/>
+                        </a:lnSpc>
+                        <a:spcBef>
+                          <a:spcPts val="0"/>
+                        </a:spcBef>
+                        <a:spcAft>
+                          <a:spcPts val="0"/>
+                        </a:spcAft>
+                        <a:buNone/>
+                        <a:defRPr sz="1300" b="0">
+                          <a:solidFill>
+                            <a:srgbClr val="14213D"/>
+                          </a:solidFill>
+                          <a:latin typeface="Arial"/>
+                        </a:defRPr>
+                      </a:pPr>
+                      <a:r>
+                        <a:rPr lang="en-US" sz="1300" b="0">
+                          <a:solidFill>
+                            <a:srgbClr val="14213D"/>
+                          </a:solidFill>
+                          <a:latin typeface="Arial"/>
+                        </a:rPr>
+                        <a:t>Prevention</a:t>
+                      </a:r>
+                    </a:p>
+                  </a:txBody>
+                  <a:tcPr>
+                    <a:lnT w="7200" cap="flat" cmpd="sng" algn="ctr">
+                      <a:solidFill>
+                        <a:srgbClr val="DCDFE5"/>
+                      </a:solidFill>
+                      <a:prstDash val="solid"/>
+                      <a:round/>
+                      <a:headEnd type="none" w="med" len="med"/>
+                      <a:tailEnd type="none" w="med" len="med"/>
+                    </a:lnT>
+                    <a:lnB w="7200" cap="flat" cmpd="sng" algn="ctr">
+                      <a:solidFill>
+                        <a:srgbClr val="DCDFE5"/>
+                      </a:solidFill>
+                      <a:prstDash val="solid"/>
+                      <a:round/>
+                      <a:headEnd type="none" w="med" len="med"/>
+                      <a:tailEnd type="none" w="med" len="med"/>
+                    </a:lnB>
+                    <a:solidFill>
+                      <a:srgbClr val="F7F6F2"/>
+                    </a:solidFill>
+                  </a:tcPr>
+                </a:tc>
+                <a:tc>
+                  <a:txBody>
+                    <a:bodyPr/>
+                    <a:lstStyle/>
+                    <a:p>
+                      <a:pPr lvl="0">
+                        <a:lnSpc>
+                          <a:spcPct val="125000"/>
+                        </a:lnSpc>
+                        <a:spcBef>
+                          <a:spcPts val="0"/>
+                        </a:spcBef>
+                        <a:spcAft>
+                          <a:spcPts val="0"/>
+                        </a:spcAft>
+                        <a:buNone/>
+                        <a:defRPr sz="1300" b="0">
+                          <a:solidFill>
+                            <a:srgbClr val="14213D"/>
+                          </a:solidFill>
+                          <a:latin typeface="Arial"/>
+                        </a:defRPr>
+                      </a:pPr>
+                      <a:r>
+                        <a:rPr lang="en-US" sz="1300" b="0">
+                          <a:solidFill>
+                            <a:srgbClr val="14213D"/>
+                          </a:solidFill>
+                          <a:latin typeface="Arial"/>
+                        </a:rPr>
+                        <a:t>Emmanuel De Jesus</a:t>
+                      </a:r>
+                    </a:p>
+                  </a:txBody>
+                  <a:tcPr>
+                    <a:lnT w="7200" cap="flat" cmpd="sng" algn="ctr">
+                      <a:solidFill>
+                        <a:srgbClr val="DCDFE5"/>
+                      </a:solidFill>
+                      <a:prstDash val="solid"/>
+                      <a:round/>
+                      <a:headEnd type="none" w="med" len="med"/>
+                      <a:tailEnd type="none" w="med" len="med"/>
+                    </a:lnT>
+                    <a:lnB w="7200" cap="flat" cmpd="sng" algn="ctr">
+                      <a:solidFill>
+                        <a:srgbClr val="DCDFE5"/>
+                      </a:solidFill>
+                      <a:prstDash val="solid"/>
+                      <a:round/>
+                      <a:headEnd type="none" w="med" len="med"/>
+                      <a:tailEnd type="none" w="med" len="med"/>
+                    </a:lnB>
+                    <a:solidFill>
+                      <a:srgbClr val="F7F6F2"/>
+                    </a:solidFill>
+                  </a:tcPr>
+                </a:tc>
+                <a:tc>
+                  <a:txBody>
+                    <a:bodyPr/>
+                    <a:lstStyle/>
+                    <a:p>
+                      <a:pPr lvl="0">
+                        <a:lnSpc>
+                          <a:spcPct val="125000"/>
+                        </a:lnSpc>
+                        <a:spcBef>
+                          <a:spcPts val="0"/>
+                        </a:spcBef>
+                        <a:spcAft>
+                          <a:spcPts val="0"/>
+                        </a:spcAft>
+                        <a:buNone/>
+                        <a:defRPr sz="1300" b="0">
+                          <a:solidFill>
+                            <a:srgbClr val="14213D"/>
+                          </a:solidFill>
+                          <a:latin typeface="Arial"/>
+                        </a:defRPr>
+                      </a:pPr>
+                      <a:r>
+                        <a:rPr lang="en-US" sz="1300" b="0">
+                          <a:solidFill>
+                            <a:srgbClr val="14213D"/>
+                          </a:solidFill>
+                          <a:latin typeface="Arial"/>
+                        </a:rPr>
+                        <a:t>Isolate context; enforce action and output contracts</a:t>
+                      </a:r>
+                    </a:p>
+                  </a:txBody>
+                  <a:tcPr>
+                    <a:lnT w="7200" cap="flat" cmpd="sng" algn="ctr">
+                      <a:solidFill>
+                        <a:srgbClr val="DCDFE5"/>
+                      </a:solidFill>
+                      <a:prstDash val="solid"/>
+                      <a:round/>
+                      <a:headEnd type="none" w="med" len="med"/>
+                      <a:tailEnd type="none" w="med" len="med"/>
+                    </a:lnT>
+                    <a:lnB w="7200" cap="flat" cmpd="sng" algn="ctr">
+                      <a:solidFill>
+                        <a:srgbClr val="DCDFE5"/>
+                      </a:solidFill>
+                      <a:prstDash val="solid"/>
+                      <a:round/>
+                      <a:headEnd type="none" w="med" len="med"/>
+                      <a:tailEnd type="none" w="med" len="med"/>
+                    </a:lnB>
+                    <a:solidFill>
+                      <a:srgbClr val="F7F6F2"/>
+                    </a:solidFill>
+                  </a:tcPr>
+                </a:tc>
+                <a:extLst>
+                  <a:ext uri="{0D108BD9-81ED-4DB2-BD59-A6C34878D82A}">
+                    <a16:rowId xmlns:a16="http://schemas.microsoft.com/office/drawing/2014/main" val="2032191303"/>
+                  </a:ext>
+                </a:extLst>
+              </a:tr>
+            </a:tbl>
+          </a:graphicData>
+        </a:graphic>
+      </p:graphicFrame>
+      <p:sp>
+        <p:nvSpPr>
+          <p:cNvPr id="9" name="Next milestone: connect the three parts end to end">
+            <a:extLst>
+              <a:ext uri="{FF2B5EF4-FFF2-40B4-BE49-F238E27FC236}">
+                <a16:creationId xmlns:a16="http://schemas.microsoft.com/office/drawing/2014/main" id="{1B42776B-B02E-645E-06CE-586C6DCFB2D2}"/>
+              </a:ext>
+            </a:extLst>
+          </p:cNvPr>
+          <p:cNvSpPr txBox="1"/>
+          <p:nvPr/>
+        </p:nvSpPr>
+        <p:spPr>
+          <a:xfrm>
+            <a:off x="812800" y="4737099"/>
+            <a:ext cx="10566399" cy="698500"/>
+          </a:xfrm>
+          <a:prstGeom prst="rect">
+            <a:avLst/>
+          </a:prstGeom>
+          <a:noFill/>
+          <a:ln>
+            <a:noFill/>
+          </a:ln>
+        </p:spPr>
+        <p:txBody>
+          <a:bodyPr lIns="0" tIns="0" rIns="0" bIns="0" anchor="t">
+            <a:noAutofit/>
+          </a:bodyPr>
+          <a:lstStyle/>
+          <a:p>
+            <a:pPr lvl="0">
+              <a:lnSpc>
+                <a:spcPct val="140000"/>
+              </a:lnSpc>
+              <a:spcBef>
+                <a:spcPts val="0"/>
+              </a:spcBef>
+              <a:spcAft>
+                <a:spcPts val="0"/>
+              </a:spcAft>
+              <a:buNone/>
+              <a:defRPr sz="1400" b="0">
+                <a:solidFill>
+                  <a:srgbClr val="4A5568"/>
+                </a:solidFill>
+                <a:latin typeface="Arial"/>
+              </a:defRPr>
+            </a:pPr>
+            <a:r>
+              <a:rPr lang="en-US" sz="1400" b="0">
+                <a:solidFill>
+                  <a:srgbClr val="4A5568"/>
+                </a:solidFill>
+                <a:latin typeface="Arial"/>
+              </a:rPr>
+              <a:t>Harness loop is live on synthetic data: it starts on a review run, checkpoints at each guard, and stops when the human report is ready (or the model answer is rejected / unavailable).</a:t>
+            </a:r>
+          </a:p>
+        </p:txBody>
+      </p:sp>
+    </p:spTree>
+  </p:cSld>
+  <p:clrMapOvr>
+    <a:masterClrMapping/>
+  </p:clrMapOvr>
+</p:sld>
 </file>
 
 <file path=ppt/slides/slide4.xml><?xml version="1.0" encoding="utf-8"?>
@@ -11413,7 +12555,7 @@
       </p:sp>
       <p:sp>
         <p:nvSpPr>
-          <p:cNvPr id="15" name="Starts When a review run begins">
+          <p:cNvPr id="15" name="01 Connect harness facts, read tools and guards; t">
             <a:extLst>
               <a:ext uri="{FF2B5EF4-FFF2-40B4-BE49-F238E27FC236}">
                 <a16:creationId xmlns:a16="http://schemas.microsoft.com/office/drawing/2014/main" id="{34235828-090F-8673-9F4F-9E3234F8B8D8}"/>

</xml_diff>